<commit_message>
Natural ecosystem slide: replace effect signs and reasons with conditions
Co-Authored-By: Claude Opus 5.5 <noreply@anthropic.com>
Claude-Session: https://claude.ai/code/session_013ce4PKS59x4i27j5CRjVKQ
</commit_message>
<xml_diff>
--- a/seminar/Natural_ecosystem_evidence_grouped.pptx
+++ b/seminar/Natural_ecosystem_evidence_grouped.pptx
@@ -107,7 +107,7 @@
   <p:extLst>
     <p:ext uri="{521415D9-36F7-43E2-AB2F-B90AF26B5E84}">
       <p14:sectionLst xmlns:p14="http://schemas.microsoft.com/office/powerpoint/2010/main">
-        <p14:section name="7 · Evidence" id="{4ac2934c-bbab-9c4b-277e-cea9500702cc}">
+        <p14:section name="7 · Evidence" id="{abee870c-d130-5c0e-df77-e35437d31fcb}">
           <p14:sldIdLst>
             <p14:sldId id="256"/>
           </p14:sldIdLst>
@@ -516,7 +516,7 @@
           <a:p>
             <a:r>
               <a:rPr lang="en-US" dirty="0"/>
-              <a:t>This slide brings together the evidence from natural ecosystems, grouped into five broad types. For each group the table shows the sign of the effect, the conditions under which it is positive or negative with the values reported, the reason, and the key references. Crop ecosystems are excluded here and treated separately.
+              <a:t>This slide brings together the evidence from natural ecosystems, grouped into five broad types. For each group the table shows the aerosol impact reported, the condition under which the effect was positive or negative in those studies, and the key references. Crop ecosystems are excluded here and treated separately.
 Boreal and temperate forests show a consistent gain. In boreal and hemiboreal forests of Finland, Estonia and Siberia, Ezhova and colleagues, 2018, found that aerosol raised the clear-day diffuse fraction from about 0.11 to 0.2–0.27 and GPP by 6 to 14 percent; the figure shows GPP peaking at an intermediate diffuse fraction. At Harvard Forest, Gu and colleagues, 2003, found that sulfate from the Mount Pinatubo eruption raised noon photosynthesis by 23 percent in 1992. Supporting studies are Strada and colleagues, 2015, with midday GPP 13 percent higher at AOD above 0.4 in the eastern United States, and Yue and colleagues, 2017, with a fire-aerosol NPP gain of 8 teragrams of carbon per year in boreal North America. The reason is the deep, multilayer canopy: diffuse light penetrates to shaded leaves that are light-limited under direct sun. Matsui and colleagues, 2008, showed that the gain is negligible when leaf area index is below 3.
 Tropical forests gain at moderate smoke but lose under very heavy smoke. In the Amazon, Oliveira and colleagues, 2007, found net ecosystem exchange increased by 8.4 to 16 percent at AOD 0.83 to 1.26, but declined above 1.7. Rap and colleagues, 2015, modelled an NPP increase of 1.4 to 2.8 percent from fire aerosol, and Moreira and colleagues, 2017, a GPP increase of 27 percent in 2010. Doughty and colleagues, 2010, found that 80 percent of the extra uptake came from diffuse light and 20 percent from canopy cooling. Cirino and colleagues, 2014, found lower photosynthetic efficiency under heavy smoke, because total PAR falls too much. Yamasoe and colleagues, 2006, found no correlation at AOD below 0.7, Rodrigues and colleagues, 2024, found a gain in a semi-deciduous forest of the southern Amazon, and in India Hari and Tyagi, 2022, found NPP of the forest zones peaking at AOD 0.38 with the gain persisting to 0.51.
 Grasslands and savannas gain little or lose. Strada and colleagues, 2015, found that AOD above 0.6 harmed grassland while forests gained; Niyogi and colleagues, 2004, also found uptake falling over grassland and rising over forest; and Jing and colleagues, 2010, found aerosol gave negative carbon uptake in a short C3 grassland in north-west China. In a northern Australian savanna, Kanniah and colleagues, 2010, found that an increase in diffuse fraction from 11 to 21 percent did not significantly change carbon flux. The reason is the short, open canopy: there are few shaded leaves to benefit from diffuse light, so the loss of direct light is not regained.
@@ -1221,26 +1221,25 @@
         </p:nvGraphicFramePr>
         <p:xfrm>
           <a:off x="457200" y="1188720"/>
-          <a:ext cx="8778240" cy="914400"/>
+          <a:ext cx="8686800" cy="914400"/>
         </p:xfrm>
         <a:graphic>
           <a:graphicData uri="http://schemas.openxmlformats.org/drawingml/2006/table">
             <a:tbl>
               <a:tblPr/>
               <a:tblGrid>
-                <a:gridCol w="1417320"/>
-                <a:gridCol w="658368"/>
-                <a:gridCol w="2788920"/>
-                <a:gridCol w="2130552"/>
+                <a:gridCol w="1463040"/>
+                <a:gridCol w="2743200"/>
+                <a:gridCol w="2697480"/>
                 <a:gridCol w="1783080"/>
               </a:tblGrid>
-              <a:tr h="310896">
+              <a:tr h="548640">
                 <a:tc>
                   <a:txBody>
                     <a:bodyPr/>
                     <a:lstStyle/>
                     <a:p>
-                      <a:pPr algn="l" indent="0" marL="0">
+                      <a:pPr indent="0" marL="0">
                         <a:buNone/>
                       </a:pPr>
                       <a:r>
@@ -1308,7 +1307,7 @@
                     <a:bodyPr/>
                     <a:lstStyle/>
                     <a:p>
-                      <a:pPr algn="ctr" indent="0" marL="0">
+                      <a:pPr indent="0" marL="0">
                         <a:buNone/>
                       </a:pPr>
                       <a:r>
@@ -1320,7 +1319,7 @@
                           <a:ea typeface="Times New Roman" pitchFamily="34" charset="-122"/>
                           <a:cs typeface="Times New Roman" pitchFamily="34" charset="-120"/>
                         </a:rPr>
-                        <a:t>Effect</a:t>
+                        <a:t>Aerosol impact</a:t>
                       </a:r>
                       <a:endParaRPr lang="en-US" sz="1400" dirty="0">
                         <a:latin typeface="Times New Roman" charset="0"/>
@@ -1376,7 +1375,7 @@
                     <a:bodyPr/>
                     <a:lstStyle/>
                     <a:p>
-                      <a:pPr algn="l" indent="0" marL="0">
+                      <a:pPr indent="0" marL="0">
                         <a:buNone/>
                       </a:pPr>
                       <a:r>
@@ -1388,7 +1387,7 @@
                           <a:ea typeface="Times New Roman" pitchFamily="34" charset="-122"/>
                           <a:cs typeface="Times New Roman" pitchFamily="34" charset="-120"/>
                         </a:rPr>
-                        <a:t>When positive or negative</a:t>
+                        <a:t>Condition for positive or negative effect</a:t>
                       </a:r>
                       <a:endParaRPr lang="en-US" sz="1400" dirty="0">
                         <a:latin typeface="Times New Roman" charset="0"/>
@@ -1444,75 +1443,7 @@
                     <a:bodyPr/>
                     <a:lstStyle/>
                     <a:p>
-                      <a:pPr algn="l" indent="0" marL="0">
-                        <a:buNone/>
-                      </a:pPr>
-                      <a:r>
-                        <a:rPr lang="en-US" sz="1400" b="1" dirty="0">
-                          <a:solidFill>
-                            <a:srgbClr val="FFFFFF"/>
-                          </a:solidFill>
-                          <a:latin typeface="Times New Roman" pitchFamily="34" charset="0"/>
-                          <a:ea typeface="Times New Roman" pitchFamily="34" charset="-122"/>
-                          <a:cs typeface="Times New Roman" pitchFamily="34" charset="-120"/>
-                        </a:rPr>
-                        <a:t>Reason</a:t>
-                      </a:r>
-                      <a:endParaRPr lang="en-US" sz="1400" dirty="0">
-                        <a:latin typeface="Times New Roman" charset="0"/>
-                        <a:ea typeface="Times New Roman" charset="0"/>
-                        <a:cs typeface="Times New Roman" charset="0"/>
-                      </a:endParaRPr>
-                    </a:p>
-                  </a:txBody>
-                  <a:tcPr marL="64008" marR="64008" marT="9144" marB="9144" anchor="ctr">
-                    <a:lnL w="6350" cap="flat" cmpd="sng" algn="ctr">
-                      <a:solidFill>
-                        <a:srgbClr val="D3DCE2"/>
-                      </a:solidFill>
-                      <a:prstDash val="solid"/>
-                      <a:round/>
-                      <a:headEnd type="none" w="med" len="med"/>
-                      <a:tailEnd type="none" w="med" len="med"/>
-                    </a:lnL>
-                    <a:lnR w="6350" cap="flat" cmpd="sng" algn="ctr">
-                      <a:solidFill>
-                        <a:srgbClr val="D3DCE2"/>
-                      </a:solidFill>
-                      <a:prstDash val="solid"/>
-                      <a:round/>
-                      <a:headEnd type="none" w="med" len="med"/>
-                      <a:tailEnd type="none" w="med" len="med"/>
-                    </a:lnR>
-                    <a:lnT w="6350" cap="flat" cmpd="sng" algn="ctr">
-                      <a:solidFill>
-                        <a:srgbClr val="D3DCE2"/>
-                      </a:solidFill>
-                      <a:prstDash val="solid"/>
-                      <a:round/>
-                      <a:headEnd type="none" w="med" len="med"/>
-                      <a:tailEnd type="none" w="med" len="med"/>
-                    </a:lnT>
-                    <a:lnB w="6350" cap="flat" cmpd="sng" algn="ctr">
-                      <a:solidFill>
-                        <a:srgbClr val="D3DCE2"/>
-                      </a:solidFill>
-                      <a:prstDash val="solid"/>
-                      <a:round/>
-                      <a:headEnd type="none" w="med" len="med"/>
-                      <a:tailEnd type="none" w="med" len="med"/>
-                    </a:lnB>
-                    <a:solidFill>
-                      <a:srgbClr val="16384A"/>
-                    </a:solidFill>
-                  </a:tcPr>
-                </a:tc>
-                <a:tc>
-                  <a:txBody>
-                    <a:bodyPr/>
-                    <a:lstStyle/>
-                    <a:p>
-                      <a:pPr algn="l" indent="0" marL="0">
+                      <a:pPr indent="0" marL="0">
                         <a:buNone/>
                       </a:pPr>
                       <a:r>
@@ -1650,74 +1581,6 @@
                     <a:bodyPr/>
                     <a:lstStyle/>
                     <a:p>
-                      <a:pPr algn="ctr" indent="0" marL="0">
-                        <a:buNone/>
-                      </a:pPr>
-                      <a:r>
-                        <a:rPr lang="en-US" sz="1600" b="1" dirty="0">
-                          <a:solidFill>
-                            <a:srgbClr val="3C8D5A"/>
-                          </a:solidFill>
-                          <a:latin typeface="Times New Roman" pitchFamily="34" charset="0"/>
-                          <a:ea typeface="Times New Roman" pitchFamily="34" charset="-122"/>
-                          <a:cs typeface="Times New Roman" pitchFamily="34" charset="-120"/>
-                        </a:rPr>
-                        <a:t>↑</a:t>
-                      </a:r>
-                      <a:endParaRPr lang="en-US" sz="1600" dirty="0">
-                        <a:latin typeface="Times New Roman" charset="0"/>
-                        <a:ea typeface="Times New Roman" charset="0"/>
-                        <a:cs typeface="Times New Roman" charset="0"/>
-                      </a:endParaRPr>
-                    </a:p>
-                  </a:txBody>
-                  <a:tcPr marL="64008" marR="64008" marT="9144" marB="9144" anchor="ctr">
-                    <a:lnL w="6350" cap="flat" cmpd="sng" algn="ctr">
-                      <a:solidFill>
-                        <a:srgbClr val="D3DCE2"/>
-                      </a:solidFill>
-                      <a:prstDash val="solid"/>
-                      <a:round/>
-                      <a:headEnd type="none" w="med" len="med"/>
-                      <a:tailEnd type="none" w="med" len="med"/>
-                    </a:lnL>
-                    <a:lnR w="6350" cap="flat" cmpd="sng" algn="ctr">
-                      <a:solidFill>
-                        <a:srgbClr val="D3DCE2"/>
-                      </a:solidFill>
-                      <a:prstDash val="solid"/>
-                      <a:round/>
-                      <a:headEnd type="none" w="med" len="med"/>
-                      <a:tailEnd type="none" w="med" len="med"/>
-                    </a:lnR>
-                    <a:lnT w="6350" cap="flat" cmpd="sng" algn="ctr">
-                      <a:solidFill>
-                        <a:srgbClr val="D3DCE2"/>
-                      </a:solidFill>
-                      <a:prstDash val="solid"/>
-                      <a:round/>
-                      <a:headEnd type="none" w="med" len="med"/>
-                      <a:tailEnd type="none" w="med" len="med"/>
-                    </a:lnT>
-                    <a:lnB w="6350" cap="flat" cmpd="sng" algn="ctr">
-                      <a:solidFill>
-                        <a:srgbClr val="D3DCE2"/>
-                      </a:solidFill>
-                      <a:prstDash val="solid"/>
-                      <a:round/>
-                      <a:headEnd type="none" w="med" len="med"/>
-                      <a:tailEnd type="none" w="med" len="med"/>
-                    </a:lnB>
-                    <a:solidFill>
-                      <a:srgbClr val="D9EED9"/>
-                    </a:solidFill>
-                  </a:tcPr>
-                </a:tc>
-                <a:tc>
-                  <a:txBody>
-                    <a:bodyPr/>
-                    <a:lstStyle/>
-                    <a:p>
                       <a:pPr indent="0" marL="0">
                         <a:buNone/>
                       </a:pPr>
@@ -1730,7 +1593,7 @@
                           <a:ea typeface="Times New Roman" pitchFamily="34" charset="-122"/>
                           <a:cs typeface="Times New Roman" pitchFamily="34" charset="-120"/>
                         </a:rPr>
-                        <a:t>Moderate AOD: GPP +6 to 14% (boreal); noon GPP +23% after Pinatubo</a:t>
+                        <a:t>GPP +6 to 14% (boreal); noon GPP +23% after Pinatubo</a:t>
                       </a:r>
                       <a:endParaRPr lang="en-US" sz="1400" dirty="0">
                         <a:latin typeface="Times New Roman" charset="0"/>
@@ -1790,6 +1653,17 @@
                         <a:buNone/>
                       </a:pPr>
                       <a:r>
+                        <a:rPr lang="en-US" sz="1400" b="1" dirty="0">
+                          <a:solidFill>
+                            <a:srgbClr val="000000"/>
+                          </a:solidFill>
+                          <a:latin typeface="Times New Roman" pitchFamily="34" charset="0"/>
+                          <a:ea typeface="Times New Roman" pitchFamily="34" charset="-122"/>
+                          <a:cs typeface="Times New Roman" pitchFamily="34" charset="-120"/>
+                        </a:rPr>
+                        <a:t>Positive</a:t>
+                      </a:r>
+                      <a:r>
                         <a:rPr lang="en-US" sz="1400" dirty="0">
                           <a:solidFill>
                             <a:srgbClr val="000000"/>
@@ -1798,7 +1672,7 @@
                           <a:ea typeface="Times New Roman" pitchFamily="34" charset="-122"/>
                           <a:cs typeface="Times New Roman" pitchFamily="34" charset="-120"/>
                         </a:rPr>
-                        <a:t>Deep canopy: diffuse light reaches shaded leaves; no gain if LAI &lt; 3</a:t>
+                        <a:t> at moderate AOD (diffuse fraction 0.2–0.27); negligible if LAI &lt; 3</a:t>
                       </a:r>
                       <a:endParaRPr lang="en-US" sz="1400" dirty="0">
                         <a:latin typeface="Times New Roman" charset="0"/>
@@ -2034,79 +1908,11 @@
                     <a:bodyPr/>
                     <a:lstStyle/>
                     <a:p>
-                      <a:pPr algn="ctr" indent="0" marL="0">
-                        <a:buNone/>
-                      </a:pPr>
-                      <a:r>
-                        <a:rPr lang="en-US" sz="1600" b="1" dirty="0">
-                          <a:solidFill>
-                            <a:srgbClr val="B07400"/>
-                          </a:solidFill>
-                          <a:latin typeface="Times New Roman" pitchFamily="34" charset="0"/>
-                          <a:ea typeface="Times New Roman" pitchFamily="34" charset="-122"/>
-                          <a:cs typeface="Times New Roman" pitchFamily="34" charset="-120"/>
-                        </a:rPr>
-                        <a:t>↑/↓</a:t>
-                      </a:r>
-                      <a:endParaRPr lang="en-US" sz="1600" dirty="0">
-                        <a:latin typeface="Times New Roman" charset="0"/>
-                        <a:ea typeface="Times New Roman" charset="0"/>
-                        <a:cs typeface="Times New Roman" charset="0"/>
-                      </a:endParaRPr>
-                    </a:p>
-                  </a:txBody>
-                  <a:tcPr marL="64008" marR="64008" marT="9144" marB="9144" anchor="ctr">
-                    <a:lnL w="6350" cap="flat" cmpd="sng" algn="ctr">
-                      <a:solidFill>
-                        <a:srgbClr val="D3DCE2"/>
-                      </a:solidFill>
-                      <a:prstDash val="solid"/>
-                      <a:round/>
-                      <a:headEnd type="none" w="med" len="med"/>
-                      <a:tailEnd type="none" w="med" len="med"/>
-                    </a:lnL>
-                    <a:lnR w="6350" cap="flat" cmpd="sng" algn="ctr">
-                      <a:solidFill>
-                        <a:srgbClr val="D3DCE2"/>
-                      </a:solidFill>
-                      <a:prstDash val="solid"/>
-                      <a:round/>
-                      <a:headEnd type="none" w="med" len="med"/>
-                      <a:tailEnd type="none" w="med" len="med"/>
-                    </a:lnR>
-                    <a:lnT w="6350" cap="flat" cmpd="sng" algn="ctr">
-                      <a:solidFill>
-                        <a:srgbClr val="D3DCE2"/>
-                      </a:solidFill>
-                      <a:prstDash val="solid"/>
-                      <a:round/>
-                      <a:headEnd type="none" w="med" len="med"/>
-                      <a:tailEnd type="none" w="med" len="med"/>
-                    </a:lnT>
-                    <a:lnB w="6350" cap="flat" cmpd="sng" algn="ctr">
-                      <a:solidFill>
-                        <a:srgbClr val="D3DCE2"/>
-                      </a:solidFill>
-                      <a:prstDash val="solid"/>
-                      <a:round/>
-                      <a:headEnd type="none" w="med" len="med"/>
-                      <a:tailEnd type="none" w="med" len="med"/>
-                    </a:lnB>
-                    <a:solidFill>
-                      <a:srgbClr val="FBEBC8"/>
-                    </a:solidFill>
-                  </a:tcPr>
-                </a:tc>
-                <a:tc>
-                  <a:txBody>
-                    <a:bodyPr/>
-                    <a:lstStyle/>
-                    <a:p>
                       <a:pPr indent="0" marL="0">
                         <a:buNone/>
                       </a:pPr>
                       <a:r>
-                        <a:rPr lang="en-US" sz="1400" b="1" dirty="0">
+                        <a:rPr lang="en-US" sz="1400" dirty="0">
                           <a:solidFill>
                             <a:srgbClr val="000000"/>
                           </a:solidFill>
@@ -2114,40 +1920,7 @@
                           <a:ea typeface="Times New Roman" pitchFamily="34" charset="-122"/>
                           <a:cs typeface="Times New Roman" pitchFamily="34" charset="-120"/>
                         </a:rPr>
-                        <a:t>+</a:t>
-                      </a:r>
-                      <a:r>
-                        <a:rPr lang="en-US" sz="1400" dirty="0">
-                          <a:solidFill>
-                            <a:srgbClr val="000000"/>
-                          </a:solidFill>
-                          <a:latin typeface="Times New Roman" pitchFamily="34" charset="0"/>
-                          <a:ea typeface="Times New Roman" pitchFamily="34" charset="-122"/>
-                          <a:cs typeface="Times New Roman" pitchFamily="34" charset="-120"/>
-                        </a:rPr>
-                        <a:t> moderate smoke: NEE +8.4–16% (AOD 0.83–1.26), NPP +1.4–2.8%; </a:t>
-                      </a:r>
-                      <a:r>
-                        <a:rPr lang="en-US" sz="1400" b="1" dirty="0">
-                          <a:solidFill>
-                            <a:srgbClr val="000000"/>
-                          </a:solidFill>
-                          <a:latin typeface="Times New Roman" pitchFamily="34" charset="0"/>
-                          <a:ea typeface="Times New Roman" pitchFamily="34" charset="-122"/>
-                          <a:cs typeface="Times New Roman" pitchFamily="34" charset="-120"/>
-                        </a:rPr>
-                        <a:t>−</a:t>
-                      </a:r>
-                      <a:r>
-                        <a:rPr lang="en-US" sz="1400" dirty="0">
-                          <a:solidFill>
-                            <a:srgbClr val="000000"/>
-                          </a:solidFill>
-                          <a:latin typeface="Times New Roman" pitchFamily="34" charset="0"/>
-                          <a:ea typeface="Times New Roman" pitchFamily="34" charset="-122"/>
-                          <a:cs typeface="Times New Roman" pitchFamily="34" charset="-120"/>
-                        </a:rPr>
-                        <a:t> at AOD &gt; 1.7</a:t>
+                        <a:t>NEE +8.4–16%; NPP +1.4–2.8%; lower photosynthetic efficiency under heavy smoke</a:t>
                       </a:r>
                       <a:endParaRPr lang="en-US" sz="1400" dirty="0">
                         <a:latin typeface="Times New Roman" charset="0"/>
@@ -2207,6 +1980,17 @@
                         <a:buNone/>
                       </a:pPr>
                       <a:r>
+                        <a:rPr lang="en-US" sz="1400" b="1" dirty="0">
+                          <a:solidFill>
+                            <a:srgbClr val="000000"/>
+                          </a:solidFill>
+                          <a:latin typeface="Times New Roman" pitchFamily="34" charset="0"/>
+                          <a:ea typeface="Times New Roman" pitchFamily="34" charset="-122"/>
+                          <a:cs typeface="Times New Roman" pitchFamily="34" charset="-120"/>
+                        </a:rPr>
+                        <a:t>Positive</a:t>
+                      </a:r>
+                      <a:r>
                         <a:rPr lang="en-US" sz="1400" dirty="0">
                           <a:solidFill>
                             <a:srgbClr val="000000"/>
@@ -2215,7 +1999,29 @@
                           <a:ea typeface="Times New Roman" pitchFamily="34" charset="-122"/>
                           <a:cs typeface="Times New Roman" pitchFamily="34" charset="-120"/>
                         </a:rPr>
-                        <a:t>Gain: 80% diffuse light, 20% canopy cooling; heavy smoke cuts total PAR</a:t>
+                        <a:t> at AOD 0.83–1.26; </a:t>
+                      </a:r>
+                      <a:r>
+                        <a:rPr lang="en-US" sz="1400" b="1" dirty="0">
+                          <a:solidFill>
+                            <a:srgbClr val="000000"/>
+                          </a:solidFill>
+                          <a:latin typeface="Times New Roman" pitchFamily="34" charset="0"/>
+                          <a:ea typeface="Times New Roman" pitchFamily="34" charset="-122"/>
+                          <a:cs typeface="Times New Roman" pitchFamily="34" charset="-120"/>
+                        </a:rPr>
+                        <a:t>negative</a:t>
+                      </a:r>
+                      <a:r>
+                        <a:rPr lang="en-US" sz="1400" dirty="0">
+                          <a:solidFill>
+                            <a:srgbClr val="000000"/>
+                          </a:solidFill>
+                          <a:latin typeface="Times New Roman" pitchFamily="34" charset="0"/>
+                          <a:ea typeface="Times New Roman" pitchFamily="34" charset="-122"/>
+                          <a:cs typeface="Times New Roman" pitchFamily="34" charset="-120"/>
+                        </a:rPr>
+                        <a:t> above AOD 1.7</a:t>
                       </a:r>
                       <a:endParaRPr lang="en-US" sz="1400" dirty="0">
                         <a:latin typeface="Times New Roman" charset="0"/>
@@ -2472,79 +2278,11 @@
                     <a:bodyPr/>
                     <a:lstStyle/>
                     <a:p>
-                      <a:pPr algn="ctr" indent="0" marL="0">
-                        <a:buNone/>
-                      </a:pPr>
-                      <a:r>
-                        <a:rPr lang="en-US" sz="1600" b="1" dirty="0">
-                          <a:solidFill>
-                            <a:srgbClr val="B5452F"/>
-                          </a:solidFill>
-                          <a:latin typeface="Times New Roman" pitchFamily="34" charset="0"/>
-                          <a:ea typeface="Times New Roman" pitchFamily="34" charset="-122"/>
-                          <a:cs typeface="Times New Roman" pitchFamily="34" charset="-120"/>
-                        </a:rPr>
-                        <a:t>↓/↔</a:t>
-                      </a:r>
-                      <a:endParaRPr lang="en-US" sz="1600" dirty="0">
-                        <a:latin typeface="Times New Roman" charset="0"/>
-                        <a:ea typeface="Times New Roman" charset="0"/>
-                        <a:cs typeface="Times New Roman" charset="0"/>
-                      </a:endParaRPr>
-                    </a:p>
-                  </a:txBody>
-                  <a:tcPr marL="64008" marR="64008" marT="9144" marB="9144" anchor="ctr">
-                    <a:lnL w="6350" cap="flat" cmpd="sng" algn="ctr">
-                      <a:solidFill>
-                        <a:srgbClr val="D3DCE2"/>
-                      </a:solidFill>
-                      <a:prstDash val="solid"/>
-                      <a:round/>
-                      <a:headEnd type="none" w="med" len="med"/>
-                      <a:tailEnd type="none" w="med" len="med"/>
-                    </a:lnL>
-                    <a:lnR w="6350" cap="flat" cmpd="sng" algn="ctr">
-                      <a:solidFill>
-                        <a:srgbClr val="D3DCE2"/>
-                      </a:solidFill>
-                      <a:prstDash val="solid"/>
-                      <a:round/>
-                      <a:headEnd type="none" w="med" len="med"/>
-                      <a:tailEnd type="none" w="med" len="med"/>
-                    </a:lnR>
-                    <a:lnT w="6350" cap="flat" cmpd="sng" algn="ctr">
-                      <a:solidFill>
-                        <a:srgbClr val="D3DCE2"/>
-                      </a:solidFill>
-                      <a:prstDash val="solid"/>
-                      <a:round/>
-                      <a:headEnd type="none" w="med" len="med"/>
-                      <a:tailEnd type="none" w="med" len="med"/>
-                    </a:lnT>
-                    <a:lnB w="6350" cap="flat" cmpd="sng" algn="ctr">
-                      <a:solidFill>
-                        <a:srgbClr val="D3DCE2"/>
-                      </a:solidFill>
-                      <a:prstDash val="solid"/>
-                      <a:round/>
-                      <a:headEnd type="none" w="med" len="med"/>
-                      <a:tailEnd type="none" w="med" len="med"/>
-                    </a:lnB>
-                    <a:solidFill>
-                      <a:srgbClr val="F6DAD3"/>
-                    </a:solidFill>
-                  </a:tcPr>
-                </a:tc>
-                <a:tc>
-                  <a:txBody>
-                    <a:bodyPr/>
-                    <a:lstStyle/>
-                    <a:p>
                       <a:pPr indent="0" marL="0">
                         <a:buNone/>
                       </a:pPr>
                       <a:r>
-                        <a:rPr lang="en-US" sz="1400" b="1" dirty="0">
+                        <a:rPr lang="en-US" sz="1400" dirty="0">
                           <a:solidFill>
                             <a:srgbClr val="000000"/>
                           </a:solidFill>
@@ -2552,18 +2290,7 @@
                           <a:ea typeface="Times New Roman" pitchFamily="34" charset="-122"/>
                           <a:cs typeface="Times New Roman" pitchFamily="34" charset="-120"/>
                         </a:rPr>
-                        <a:t>−</a:t>
-                      </a:r>
-                      <a:r>
-                        <a:rPr lang="en-US" sz="1400" dirty="0">
-                          <a:solidFill>
-                            <a:srgbClr val="000000"/>
-                          </a:solidFill>
-                          <a:latin typeface="Times New Roman" pitchFamily="34" charset="0"/>
-                          <a:ea typeface="Times New Roman" pitchFamily="34" charset="-122"/>
-                          <a:cs typeface="Times New Roman" pitchFamily="34" charset="-120"/>
-                        </a:rPr>
-                        <a:t> grassland at AOD &gt; 0.6; savanna: diffuse 11 → 21%, no significant change</a:t>
+                        <a:t>Grassland uptake fell (USA, NW China); savanna: diffuse 11 → 21%, no significant change</a:t>
                       </a:r>
                       <a:endParaRPr lang="en-US" sz="1400" dirty="0">
                         <a:latin typeface="Times New Roman" charset="0"/>
@@ -2623,6 +2350,17 @@
                         <a:buNone/>
                       </a:pPr>
                       <a:r>
+                        <a:rPr lang="en-US" sz="1400" b="1" dirty="0">
+                          <a:solidFill>
+                            <a:srgbClr val="000000"/>
+                          </a:solidFill>
+                          <a:latin typeface="Times New Roman" pitchFamily="34" charset="0"/>
+                          <a:ea typeface="Times New Roman" pitchFamily="34" charset="-122"/>
+                          <a:cs typeface="Times New Roman" pitchFamily="34" charset="-120"/>
+                        </a:rPr>
+                        <a:t>Negative</a:t>
+                      </a:r>
+                      <a:r>
                         <a:rPr lang="en-US" sz="1400" dirty="0">
                           <a:solidFill>
                             <a:srgbClr val="000000"/>
@@ -2631,7 +2369,7 @@
                           <a:ea typeface="Times New Roman" pitchFamily="34" charset="-122"/>
                           <a:cs typeface="Times New Roman" pitchFamily="34" charset="-120"/>
                         </a:rPr>
-                        <a:t>Short, open canopy: few shaded leaves, lost direct light not regained</a:t>
+                        <a:t> at AOD &gt; 0.6 in short, open canopy; no change in open savanna</a:t>
                       </a:r>
                       <a:endParaRPr lang="en-US" sz="1400" dirty="0">
                         <a:latin typeface="Times New Roman" charset="0"/>
@@ -2867,79 +2605,11 @@
                     <a:bodyPr/>
                     <a:lstStyle/>
                     <a:p>
-                      <a:pPr algn="ctr" indent="0" marL="0">
-                        <a:buNone/>
-                      </a:pPr>
-                      <a:r>
-                        <a:rPr lang="en-US" sz="1600" b="1" dirty="0">
-                          <a:solidFill>
-                            <a:srgbClr val="B07400"/>
-                          </a:solidFill>
-                          <a:latin typeface="Times New Roman" pitchFamily="34" charset="0"/>
-                          <a:ea typeface="Times New Roman" pitchFamily="34" charset="-122"/>
-                          <a:cs typeface="Times New Roman" pitchFamily="34" charset="-120"/>
-                        </a:rPr>
-                        <a:t>↑/↓</a:t>
-                      </a:r>
-                      <a:endParaRPr lang="en-US" sz="1600" dirty="0">
-                        <a:latin typeface="Times New Roman" charset="0"/>
-                        <a:ea typeface="Times New Roman" charset="0"/>
-                        <a:cs typeface="Times New Roman" charset="0"/>
-                      </a:endParaRPr>
-                    </a:p>
-                  </a:txBody>
-                  <a:tcPr marL="64008" marR="64008" marT="9144" marB="9144" anchor="ctr">
-                    <a:lnL w="6350" cap="flat" cmpd="sng" algn="ctr">
-                      <a:solidFill>
-                        <a:srgbClr val="D3DCE2"/>
-                      </a:solidFill>
-                      <a:prstDash val="solid"/>
-                      <a:round/>
-                      <a:headEnd type="none" w="med" len="med"/>
-                      <a:tailEnd type="none" w="med" len="med"/>
-                    </a:lnL>
-                    <a:lnR w="6350" cap="flat" cmpd="sng" algn="ctr">
-                      <a:solidFill>
-                        <a:srgbClr val="D3DCE2"/>
-                      </a:solidFill>
-                      <a:prstDash val="solid"/>
-                      <a:round/>
-                      <a:headEnd type="none" w="med" len="med"/>
-                      <a:tailEnd type="none" w="med" len="med"/>
-                    </a:lnR>
-                    <a:lnT w="6350" cap="flat" cmpd="sng" algn="ctr">
-                      <a:solidFill>
-                        <a:srgbClr val="D3DCE2"/>
-                      </a:solidFill>
-                      <a:prstDash val="solid"/>
-                      <a:round/>
-                      <a:headEnd type="none" w="med" len="med"/>
-                      <a:tailEnd type="none" w="med" len="med"/>
-                    </a:lnT>
-                    <a:lnB w="6350" cap="flat" cmpd="sng" algn="ctr">
-                      <a:solidFill>
-                        <a:srgbClr val="D3DCE2"/>
-                      </a:solidFill>
-                      <a:prstDash val="solid"/>
-                      <a:round/>
-                      <a:headEnd type="none" w="med" len="med"/>
-                      <a:tailEnd type="none" w="med" len="med"/>
-                    </a:lnB>
-                    <a:solidFill>
-                      <a:srgbClr val="FBEBC8"/>
-                    </a:solidFill>
-                  </a:tcPr>
-                </a:tc>
-                <a:tc>
-                  <a:txBody>
-                    <a:bodyPr/>
-                    <a:lstStyle/>
-                    <a:p>
                       <a:pPr indent="0" marL="0">
                         <a:buNone/>
                       </a:pPr>
                       <a:r>
-                        <a:rPr lang="en-US" sz="1400" b="1" dirty="0">
+                        <a:rPr lang="en-US" sz="1400" dirty="0">
                           <a:solidFill>
                             <a:srgbClr val="000000"/>
                           </a:solidFill>
@@ -2947,40 +2617,7 @@
                           <a:ea typeface="Times New Roman" pitchFamily="34" charset="-122"/>
                           <a:cs typeface="Times New Roman" pitchFamily="34" charset="-120"/>
                         </a:rPr>
-                        <a:t>+</a:t>
-                      </a:r>
-                      <a:r>
-                        <a:rPr lang="en-US" sz="1400" dirty="0">
-                          <a:solidFill>
-                            <a:srgbClr val="000000"/>
-                          </a:solidFill>
-                          <a:latin typeface="Times New Roman" pitchFamily="34" charset="0"/>
-                          <a:ea typeface="Times New Roman" pitchFamily="34" charset="-122"/>
-                          <a:cs typeface="Times New Roman" pitchFamily="34" charset="-120"/>
-                        </a:rPr>
-                        <a:t> wildfire smoke: GPP +1.2–4.1% (California); </a:t>
-                      </a:r>
-                      <a:r>
-                        <a:rPr lang="en-US" sz="1400" b="1" dirty="0">
-                          <a:solidFill>
-                            <a:srgbClr val="000000"/>
-                          </a:solidFill>
-                          <a:latin typeface="Times New Roman" pitchFamily="34" charset="0"/>
-                          <a:ea typeface="Times New Roman" pitchFamily="34" charset="-122"/>
-                          <a:cs typeface="Times New Roman" pitchFamily="34" charset="-120"/>
-                        </a:rPr>
-                        <a:t>−</a:t>
-                      </a:r>
-                      <a:r>
-                        <a:rPr lang="en-US" sz="1400" dirty="0">
-                          <a:solidFill>
-                            <a:srgbClr val="000000"/>
-                          </a:solidFill>
-                          <a:latin typeface="Times New Roman" pitchFamily="34" charset="0"/>
-                          <a:ea typeface="Times New Roman" pitchFamily="34" charset="-122"/>
-                          <a:cs typeface="Times New Roman" pitchFamily="34" charset="-120"/>
-                        </a:rPr>
-                        <a:t> black carbon (Pantanal)</a:t>
+                        <a:t>GPP +1.2–4.1% (California); assimilation lowered (Pantanal)</a:t>
                       </a:r>
                       <a:endParaRPr lang="en-US" sz="1400" dirty="0">
                         <a:latin typeface="Times New Roman" charset="0"/>
@@ -3040,6 +2677,17 @@
                         <a:buNone/>
                       </a:pPr>
                       <a:r>
+                        <a:rPr lang="en-US" sz="1400" b="1" dirty="0">
+                          <a:solidFill>
+                            <a:srgbClr val="000000"/>
+                          </a:solidFill>
+                          <a:latin typeface="Times New Roman" pitchFamily="34" charset="0"/>
+                          <a:ea typeface="Times New Roman" pitchFamily="34" charset="-122"/>
+                          <a:cs typeface="Times New Roman" pitchFamily="34" charset="-120"/>
+                        </a:rPr>
+                        <a:t>Positive</a:t>
+                      </a:r>
+                      <a:r>
                         <a:rPr lang="en-US" sz="1400" dirty="0">
                           <a:solidFill>
                             <a:srgbClr val="000000"/>
@@ -3048,7 +2696,29 @@
                           <a:ea typeface="Times New Roman" pitchFamily="34" charset="-122"/>
                           <a:cs typeface="Times New Roman" pitchFamily="34" charset="-120"/>
                         </a:rPr>
-                        <a:t>Scattering adds diffuse light; black carbon absorbs PAR</a:t>
+                        <a:t> under scattering wildfire smoke; </a:t>
+                      </a:r>
+                      <a:r>
+                        <a:rPr lang="en-US" sz="1400" b="1" dirty="0">
+                          <a:solidFill>
+                            <a:srgbClr val="000000"/>
+                          </a:solidFill>
+                          <a:latin typeface="Times New Roman" pitchFamily="34" charset="0"/>
+                          <a:ea typeface="Times New Roman" pitchFamily="34" charset="-122"/>
+                          <a:cs typeface="Times New Roman" pitchFamily="34" charset="-120"/>
+                        </a:rPr>
+                        <a:t>negative</a:t>
+                      </a:r>
+                      <a:r>
+                        <a:rPr lang="en-US" sz="1400" dirty="0">
+                          <a:solidFill>
+                            <a:srgbClr val="000000"/>
+                          </a:solidFill>
+                          <a:latin typeface="Times New Roman" pitchFamily="34" charset="0"/>
+                          <a:ea typeface="Times New Roman" pitchFamily="34" charset="-122"/>
+                          <a:cs typeface="Times New Roman" pitchFamily="34" charset="-120"/>
+                        </a:rPr>
+                        <a:t> under black carbon</a:t>
                       </a:r>
                       <a:endParaRPr lang="en-US" sz="1400" dirty="0">
                         <a:latin typeface="Times New Roman" charset="0"/>
@@ -3263,74 +2933,6 @@
                     <a:bodyPr/>
                     <a:lstStyle/>
                     <a:p>
-                      <a:pPr algn="ctr" indent="0" marL="0">
-                        <a:buNone/>
-                      </a:pPr>
-                      <a:r>
-                        <a:rPr lang="en-US" sz="1600" b="1" dirty="0">
-                          <a:solidFill>
-                            <a:srgbClr val="3C8D5A"/>
-                          </a:solidFill>
-                          <a:latin typeface="Times New Roman" pitchFamily="34" charset="0"/>
-                          <a:ea typeface="Times New Roman" pitchFamily="34" charset="-122"/>
-                          <a:cs typeface="Times New Roman" pitchFamily="34" charset="-120"/>
-                        </a:rPr>
-                        <a:t>↑</a:t>
-                      </a:r>
-                      <a:endParaRPr lang="en-US" sz="1600" dirty="0">
-                        <a:latin typeface="Times New Roman" charset="0"/>
-                        <a:ea typeface="Times New Roman" charset="0"/>
-                        <a:cs typeface="Times New Roman" charset="0"/>
-                      </a:endParaRPr>
-                    </a:p>
-                  </a:txBody>
-                  <a:tcPr marL="64008" marR="64008" marT="9144" marB="9144" anchor="ctr">
-                    <a:lnL w="6350" cap="flat" cmpd="sng" algn="ctr">
-                      <a:solidFill>
-                        <a:srgbClr val="D3DCE2"/>
-                      </a:solidFill>
-                      <a:prstDash val="solid"/>
-                      <a:round/>
-                      <a:headEnd type="none" w="med" len="med"/>
-                      <a:tailEnd type="none" w="med" len="med"/>
-                    </a:lnL>
-                    <a:lnR w="6350" cap="flat" cmpd="sng" algn="ctr">
-                      <a:solidFill>
-                        <a:srgbClr val="D3DCE2"/>
-                      </a:solidFill>
-                      <a:prstDash val="solid"/>
-                      <a:round/>
-                      <a:headEnd type="none" w="med" len="med"/>
-                      <a:tailEnd type="none" w="med" len="med"/>
-                    </a:lnR>
-                    <a:lnT w="6350" cap="flat" cmpd="sng" algn="ctr">
-                      <a:solidFill>
-                        <a:srgbClr val="D3DCE2"/>
-                      </a:solidFill>
-                      <a:prstDash val="solid"/>
-                      <a:round/>
-                      <a:headEnd type="none" w="med" len="med"/>
-                      <a:tailEnd type="none" w="med" len="med"/>
-                    </a:lnT>
-                    <a:lnB w="6350" cap="flat" cmpd="sng" algn="ctr">
-                      <a:solidFill>
-                        <a:srgbClr val="D3DCE2"/>
-                      </a:solidFill>
-                      <a:prstDash val="solid"/>
-                      <a:round/>
-                      <a:headEnd type="none" w="med" len="med"/>
-                      <a:tailEnd type="none" w="med" len="med"/>
-                    </a:lnB>
-                    <a:solidFill>
-                      <a:srgbClr val="D9EED9"/>
-                    </a:solidFill>
-                  </a:tcPr>
-                </a:tc>
-                <a:tc>
-                  <a:txBody>
-                    <a:bodyPr/>
-                    <a:lstStyle/>
-                    <a:p>
                       <a:pPr indent="0" marL="0">
                         <a:buNone/>
                       </a:pPr>
@@ -3343,7 +2945,7 @@
                           <a:ea typeface="Times New Roman" pitchFamily="34" charset="-122"/>
                           <a:cs typeface="Times New Roman" pitchFamily="34" charset="-120"/>
                         </a:rPr>
-                        <a:t>NPP +1.23 Pg C yr</a:t>
+                        <a:t>NPP +1.23, GPP +0.95 Pg C yr</a:t>
                       </a:r>
                       <a:r>
                         <a:rPr lang="en-US" sz="1400" baseline="30000" dirty="0">
@@ -3365,7 +2967,7 @@
                           <a:ea typeface="Times New Roman" pitchFamily="34" charset="-122"/>
                           <a:cs typeface="Times New Roman" pitchFamily="34" charset="-120"/>
                         </a:rPr>
-                        <a:t>; GPP +0.95 (all-sky) vs +8.9 (clear-sky); land sink ~¼ higher (1960–1999)</a:t>
+                        <a:t>; land sink ~¼ higher in 1960‑1999</a:t>
                       </a:r>
                       <a:endParaRPr lang="en-US" sz="1400" dirty="0">
                         <a:latin typeface="Times New Roman" charset="0"/>
@@ -3425,6 +3027,17 @@
                         <a:buNone/>
                       </a:pPr>
                       <a:r>
+                        <a:rPr lang="en-US" sz="1400" b="1" dirty="0">
+                          <a:solidFill>
+                            <a:srgbClr val="000000"/>
+                          </a:solidFill>
+                          <a:latin typeface="Times New Roman" pitchFamily="34" charset="0"/>
+                          <a:ea typeface="Times New Roman" pitchFamily="34" charset="-122"/>
+                          <a:cs typeface="Times New Roman" pitchFamily="34" charset="-120"/>
+                        </a:rPr>
+                        <a:t>Positive</a:t>
+                      </a:r>
+                      <a:r>
                         <a:rPr lang="en-US" sz="1400" dirty="0">
                           <a:solidFill>
                             <a:srgbClr val="000000"/>
@@ -3433,7 +3046,7 @@
                           <a:ea typeface="Times New Roman" pitchFamily="34" charset="-122"/>
                           <a:cs typeface="Times New Roman" pitchFamily="34" charset="-120"/>
                         </a:rPr>
-                        <a:t>Gain mostly over forests; clouds already make light diffuse</a:t>
+                        <a:t> overall; smaller under clouds (all‑sky +0.95 vs clear‑sky +8.9)</a:t>
                       </a:r>
                       <a:endParaRPr lang="en-US" sz="1400" dirty="0">
                         <a:latin typeface="Times New Roman" charset="0"/>
@@ -3769,14 +3382,14 @@
       </p:sp>
       <p:sp>
         <p:nvSpPr>
-          <p:cNvPr id="10" name="Effect legend"/>
+          <p:cNvPr id="10" name="Crop note"/>
           <p:cNvSpPr txBox="1"/>
           <p:nvPr/>
         </p:nvSpPr>
         <p:spPr>
           <a:xfrm>
             <a:off x="9326880" y="4846320"/>
-            <a:ext cx="2404872" cy="685800"/>
+            <a:ext cx="2404872" cy="274320"/>
           </a:xfrm>
           <a:prstGeom prst="rect">
             <a:avLst/>
@@ -3787,82 +3400,6 @@
         <p:txBody>
           <a:bodyPr wrap="square" lIns="0" tIns="0" rIns="0" bIns="0" rtlCol="0" anchor="t"/>
           <a:lstStyle/>
-          <a:p>
-            <a:pPr indent="0" marL="0">
-              <a:buNone/>
-            </a:pPr>
-            <a:r>
-              <a:rPr lang="en-US" sz="1400" b="1" dirty="0">
-                <a:solidFill>
-                  <a:srgbClr val="3C8D5A"/>
-                </a:solidFill>
-              </a:rPr>
-              <a:t>↑ </a:t>
-            </a:r>
-            <a:r>
-              <a:rPr lang="en-US" sz="1400" dirty="0">
-                <a:solidFill>
-                  <a:srgbClr val="1A1F24"/>
-                </a:solidFill>
-              </a:rPr>
-              <a:t>increase   </a:t>
-            </a:r>
-            <a:r>
-              <a:rPr lang="en-US" sz="1400" b="1" dirty="0">
-                <a:solidFill>
-                  <a:srgbClr val="5A6B78"/>
-                </a:solidFill>
-              </a:rPr>
-              <a:t>↔ </a:t>
-            </a:r>
-            <a:r>
-              <a:rPr lang="en-US" sz="1400" dirty="0">
-                <a:solidFill>
-                  <a:srgbClr val="1A1F24"/>
-                </a:solidFill>
-              </a:rPr>
-              <a:t>no clear change</a:t>
-            </a:r>
-            <a:endParaRPr lang="en-US" sz="1400" dirty="0"/>
-          </a:p>
-          <a:p>
-            <a:pPr indent="0" marL="0">
-              <a:buNone/>
-            </a:pPr>
-            <a:r>
-              <a:rPr lang="en-US" sz="1400" b="1" dirty="0">
-                <a:solidFill>
-                  <a:srgbClr val="B5452F"/>
-                </a:solidFill>
-              </a:rPr>
-              <a:t>↓ </a:t>
-            </a:r>
-            <a:r>
-              <a:rPr lang="en-US" sz="1400" dirty="0">
-                <a:solidFill>
-                  <a:srgbClr val="1A1F24"/>
-                </a:solidFill>
-              </a:rPr>
-              <a:t>decrease   </a:t>
-            </a:r>
-            <a:r>
-              <a:rPr lang="en-US" sz="1400" b="1" dirty="0">
-                <a:solidFill>
-                  <a:srgbClr val="B07400"/>
-                </a:solidFill>
-              </a:rPr>
-              <a:t>↑/↓ </a:t>
-            </a:r>
-            <a:r>
-              <a:rPr lang="en-US" sz="1400" dirty="0">
-                <a:solidFill>
-                  <a:srgbClr val="1A1F24"/>
-                </a:solidFill>
-              </a:rPr>
-              <a:t>depends on load</a:t>
-            </a:r>
-            <a:endParaRPr lang="en-US" sz="1400" dirty="0"/>
-          </a:p>
           <a:p>
             <a:pPr indent="0" marL="0">
               <a:buNone/>

</xml_diff>

<commit_message>
Lighten natural ecosystem evidence slide and fix reference placement
Move Matsui et al., 2008 (LAI < 3 finding) to the grassland row, describe
Ezhova boreal sites as low aerosol load, and keep only references backing
each on-slide value.

Co-Authored-By: Claude Opus 5.5 <noreply@anthropic.com>
Claude-Session: https://claude.ai/code/session_013ce4PKS59x4i27j5CRjVKQ
</commit_message>
<xml_diff>
--- a/seminar/Natural_ecosystem_evidence_grouped.pptx
+++ b/seminar/Natural_ecosystem_evidence_grouped.pptx
@@ -107,7 +107,7 @@
   <p:extLst>
     <p:ext uri="{521415D9-36F7-43E2-AB2F-B90AF26B5E84}">
       <p14:sectionLst xmlns:p14="http://schemas.microsoft.com/office/powerpoint/2010/main">
-        <p14:section name="7 · Evidence" id="{abee870c-d130-5c0e-df77-e35437d31fcb}">
+        <p14:section name="7 · Evidence" id="{c38a2d64-1ee1-f63f-5a9e-1a761c5b3ef2}">
           <p14:sldIdLst>
             <p14:sldId id="256"/>
           </p14:sldIdLst>
@@ -516,13 +516,13 @@
           <a:p>
             <a:r>
               <a:rPr lang="en-US" dirty="0"/>
-              <a:t>This slide brings together the evidence from natural ecosystems, grouped into five broad types. For each group the table shows the aerosol impact reported, the condition under which the effect was positive or negative in those studies, and the key references. Crop ecosystems are excluded here and treated separately.
-Boreal and temperate forests show a consistent gain. In boreal and hemiboreal forests of Finland, Estonia and Siberia, Ezhova and colleagues, 2018, found that aerosol raised the clear-day diffuse fraction from about 0.11 to 0.2–0.27 and GPP by 6 to 14 percent; the figure shows GPP peaking at an intermediate diffuse fraction. At Harvard Forest, Gu and colleagues, 2003, found that sulfate from the Mount Pinatubo eruption raised noon photosynthesis by 23 percent in 1992. Supporting studies are Strada and colleagues, 2015, with midday GPP 13 percent higher at AOD above 0.4 in the eastern United States, and Yue and colleagues, 2017, with a fire-aerosol NPP gain of 8 teragrams of carbon per year in boreal North America. The reason is the deep, multilayer canopy: diffuse light penetrates to shaded leaves that are light-limited under direct sun. Matsui and colleagues, 2008, showed that the gain is negligible when leaf area index is below 3.
-Tropical forests gain at moderate smoke but lose under very heavy smoke. In the Amazon, Oliveira and colleagues, 2007, found net ecosystem exchange increased by 8.4 to 16 percent at AOD 0.83 to 1.26, but declined above 1.7. Rap and colleagues, 2015, modelled an NPP increase of 1.4 to 2.8 percent from fire aerosol, and Moreira and colleagues, 2017, a GPP increase of 27 percent in 2010. Doughty and colleagues, 2010, found that 80 percent of the extra uptake came from diffuse light and 20 percent from canopy cooling. Cirino and colleagues, 2014, found lower photosynthetic efficiency under heavy smoke, because total PAR falls too much. Yamasoe and colleagues, 2006, found no correlation at AOD below 0.7, Rodrigues and colleagues, 2024, found a gain in a semi-deciduous forest of the southern Amazon, and in India Hari and Tyagi, 2022, found NPP of the forest zones peaking at AOD 0.38 with the gain persisting to 0.51.
-Grasslands and savannas gain little or lose. Strada and colleagues, 2015, found that AOD above 0.6 harmed grassland while forests gained; Niyogi and colleagues, 2004, also found uptake falling over grassland and rising over forest; and Jing and colleagues, 2010, found aerosol gave negative carbon uptake in a short C3 grassland in north-west China. In a northern Australian savanna, Kanniah and colleagues, 2010, found that an increase in diffuse fraction from 11 to 21 percent did not significantly change carbon flux. The reason is the short, open canopy: there are few shaded leaves to benefit from diffuse light, so the loss of direct light is not regained.
-Wetlands depend on the type of aerosol. In a restored wetland in California, Hemes and colleagues, 2020, found that scattering wildfire smoke raised light-use efficiency and GPP by 1.2 to 4.1 percent, while in the Brazilian Pantanal, Curado and colleagues, 2024, found that black carbon from biomass burning reduced PAR and carbon assimilation.
-Globally the net effect is a modest gain. Rap and colleagues, 2018, estimated that secondary organic aerosol from plant emissions raises global NPP by 1.23 petagrams of carbon per year. Zhou and colleagues, 2022, found a GPP gain of 0.95 petagrams under all-sky conditions compared with 8.9 under clear skies, because clouds already make light diffuse. Mercado and colleagues, 2009, estimated that the diffuse effect raised the land carbon sink by about a quarter between 1960 and 1999. Yue and Unger, 2018, about 1.0 petagram per year, and Strada and Unger, 2016, 1 to 2 percent, give similar values. The gain comes mostly from forests.
-The strip summarises the conditions. The effect is positive with scattering aerosol, moderate aerosol load, a deep multilayer canopy and clear skies. It is negative with very high aerosol load, above about 0.6 for grassland and 1.7 for tropical forest, with absorbing black carbon, and with short open canopies.</a:t>
+              <a:t>This slide brings together the evidence from natural ecosystems, grouped into five broad types. Crop ecosystems are treated on the next slides. For each group the table gives the reported impact, the condition under which the effect was positive or negative, and the key references.
+Boreal and temperate forests. Ezhova and colleagues, 2018, worked at five boreal and hemiboreal forest sites in Finland, Estonia and Siberia. Aerosol loading at these remote sites was low, AOD at 500 nm below 0.25, yet aerosols raised the clear-day diffuse fraction from about 0.11 to 0.2–0.27, and GPP rose by 6 to 14 percent. The reason is the deep, multilayer canopy: diffuse light reaches shaded leaves that are light-limited under direct sun, so the rise in light-use efficiency outweighs the small loss of total radiation. The figure shows this as a parabola: GPP equals light-use efficiency times PAR, light-use efficiency rises with diffuse fraction while PAR falls, so GPP peaks at an intermediate diffuse fraction. At Harvard Forest, Gu and colleagues, 2003, found that sulfate aerosol from the 1991 Mount Pinatubo eruption almost doubled clear-sky diffuse radiation and raised noon photosynthesis by 23 percent in 1992.
+Tropical forest, the Amazon. Oliveira and colleagues, 2007, found net ecosystem exchange increased by 8.4 to 16 percent at AOD 0.83 to 1.26 during the burning season, but declined above AOD 1.7, because at such heavy smoke the loss of total radiation is too large. Rap and colleagues, 2015, modelled that fire aerosol over 1998–2007 increased diffuse radiation by 3.4 to 6.8 percent and NPP by 1.4 to 2.8 percent. Supporting this, Doughty and colleagues, 2010, attributed 80 percent of the extra CO2 uptake under high AOD to diffuse light and 20 percent to lower temperature, and Cirino and colleagues, 2014, found higher photosynthetic efficiency at low AOD than under heavy aerosol and thick cloud.
+Grassland and savanna. Using flux sites in the eastern United States, Strada and colleagues, 2015, found that AOD above 0.6 enhanced productivity in forests but had a negative effect in croplands and grasslands. Matsui and colleagues, 2008, explain why: NPP rose by up to 35 grams of carbon per square metre for forest, but the effect was negligible for croplands and grasslands with leaf area index below 3, because a short open canopy has few shaded leaves to gain from diffuse light. Jing and colleagues, 2010, likewise found aerosols gave negative carbon uptake over the semi-arid loess plateau of north-west China. In a savanna at Howard Springs, northern Australia, Kanniah and colleagues, 2010, found that a rise in diffuse fraction from 11 to 21 percent did not significantly change carbon flux.
+Wetland. The type of aerosol decides the sign. In a restored wetland in California, Hemes and colleagues, 2020, found that scattering wildfire smoke raised light-use efficiency and GPP by 1.2 to 4.1 percent compared with the previous growing season. In the Brazilian Pantanal, Curado and colleagues, 2024, found that high black carbon during biomass burning reduced available PAR, raised air temperature and lowered carbon assimilation.
+All biomes. Zhou and colleagues, 2022, estimated that aerosol diffuse fertilisation raises global GPP by 0.95 petagrams of carbon per year under all-sky conditions but by 8.91 under clear skies, because clouds already make light diffuse; black carbon alone reduces GPP by 0.28. Rap and colleagues, 2018, found that biogenic secondary organic aerosol raises global NPP by 1.23 petagrams per year. Mercado and colleagues, 2009, estimated that diffuse radiation changes raised the land carbon sink by about one quarter between 1960 and 1999.
+The strip summarises the pattern. The effect is positive with scattering aerosol, moderate load, a deep multilayer canopy and clear skies; it turns negative with very heavy loading, absorbing black carbon, or a short open canopy.</a:t>
             </a:r>
             <a:endParaRPr lang="en-US" dirty="0"/>
           </a:p>
@@ -1220,7 +1220,7 @@
           </p:nvPr>
         </p:nvGraphicFramePr>
         <p:xfrm>
-          <a:off x="457200" y="1188720"/>
+          <a:off x="457200" y="1280160"/>
           <a:ext cx="8686800" cy="914400"/>
         </p:xfrm>
         <a:graphic>
@@ -1228,12 +1228,12 @@
             <a:tbl>
               <a:tblPr/>
               <a:tblGrid>
-                <a:gridCol w="1463040"/>
-                <a:gridCol w="2743200"/>
+                <a:gridCol w="1600200"/>
                 <a:gridCol w="2697480"/>
+                <a:gridCol w="2606040"/>
                 <a:gridCol w="1783080"/>
               </a:tblGrid>
-              <a:tr h="548640">
+              <a:tr h="384048">
                 <a:tc>
                   <a:txBody>
                     <a:bodyPr/>
@@ -1245,7 +1245,7 @@
                       <a:r>
                         <a:rPr lang="en-US" sz="1400" b="1" dirty="0">
                           <a:solidFill>
-                            <a:srgbClr val="FFFFFF"/>
+                            <a:schemeClr val="accent1"/>
                           </a:solidFill>
                           <a:latin typeface="Times New Roman" pitchFamily="34" charset="0"/>
                           <a:ea typeface="Times New Roman" pitchFamily="34" charset="-122"/>
@@ -1260,35 +1260,207 @@
                       </a:endParaRPr>
                     </a:p>
                   </a:txBody>
-                  <a:tcPr marL="64008" marR="64008" marT="9144" marB="9144" anchor="ctr">
-                    <a:lnL w="6350" cap="flat" cmpd="sng" algn="ctr">
+                  <a:tcPr marL="73152" marR="73152" marT="36576" marB="36576" anchor="b">
+                    <a:lnL w="0" cap="flat" cmpd="sng" algn="ctr">
+                      <a:noFill/>
+                    </a:lnL>
+                    <a:lnR w="0" cap="flat" cmpd="sng" algn="ctr">
+                      <a:noFill/>
+                    </a:lnR>
+                    <a:lnT w="0" cap="flat" cmpd="sng" algn="ctr">
+                      <a:noFill/>
+                    </a:lnT>
+                    <a:lnB w="19050" cap="flat" cmpd="sng" algn="ctr">
                       <a:solidFill>
-                        <a:srgbClr val="D3DCE2"/>
+                        <a:srgbClr val="1F6F8B"/>
                       </a:solidFill>
                       <a:prstDash val="solid"/>
                       <a:round/>
                       <a:headEnd type="none" w="med" len="med"/>
                       <a:tailEnd type="none" w="med" len="med"/>
+                    </a:lnB>
+                  </a:tcPr>
+                </a:tc>
+                <a:tc>
+                  <a:txBody>
+                    <a:bodyPr/>
+                    <a:lstStyle/>
+                    <a:p>
+                      <a:pPr indent="0" marL="0">
+                        <a:buNone/>
+                      </a:pPr>
+                      <a:r>
+                        <a:rPr lang="en-US" sz="1400" b="1" dirty="0">
+                          <a:solidFill>
+                            <a:schemeClr val="accent1"/>
+                          </a:solidFill>
+                          <a:latin typeface="Times New Roman" pitchFamily="34" charset="0"/>
+                          <a:ea typeface="Times New Roman" pitchFamily="34" charset="-122"/>
+                          <a:cs typeface="Times New Roman" pitchFamily="34" charset="-120"/>
+                        </a:rPr>
+                        <a:t>Aerosol impact</a:t>
+                      </a:r>
+                      <a:endParaRPr lang="en-US" sz="1400" dirty="0">
+                        <a:latin typeface="Times New Roman" charset="0"/>
+                        <a:ea typeface="Times New Roman" charset="0"/>
+                        <a:cs typeface="Times New Roman" charset="0"/>
+                      </a:endParaRPr>
+                    </a:p>
+                  </a:txBody>
+                  <a:tcPr marL="73152" marR="73152" marT="36576" marB="36576" anchor="b">
+                    <a:lnL w="0" cap="flat" cmpd="sng" algn="ctr">
+                      <a:noFill/>
                     </a:lnL>
-                    <a:lnR w="6350" cap="flat" cmpd="sng" algn="ctr">
+                    <a:lnR w="0" cap="flat" cmpd="sng" algn="ctr">
+                      <a:noFill/>
+                    </a:lnR>
+                    <a:lnT w="0" cap="flat" cmpd="sng" algn="ctr">
+                      <a:noFill/>
+                    </a:lnT>
+                    <a:lnB w="19050" cap="flat" cmpd="sng" algn="ctr">
                       <a:solidFill>
-                        <a:srgbClr val="D3DCE2"/>
+                        <a:srgbClr val="1F6F8B"/>
                       </a:solidFill>
                       <a:prstDash val="solid"/>
                       <a:round/>
                       <a:headEnd type="none" w="med" len="med"/>
                       <a:tailEnd type="none" w="med" len="med"/>
+                    </a:lnB>
+                  </a:tcPr>
+                </a:tc>
+                <a:tc>
+                  <a:txBody>
+                    <a:bodyPr/>
+                    <a:lstStyle/>
+                    <a:p>
+                      <a:pPr indent="0" marL="0">
+                        <a:buNone/>
+                      </a:pPr>
+                      <a:r>
+                        <a:rPr lang="en-US" sz="1400" b="1" dirty="0">
+                          <a:solidFill>
+                            <a:schemeClr val="accent1"/>
+                          </a:solidFill>
+                          <a:latin typeface="Times New Roman" pitchFamily="34" charset="0"/>
+                          <a:ea typeface="Times New Roman" pitchFamily="34" charset="-122"/>
+                          <a:cs typeface="Times New Roman" pitchFamily="34" charset="-120"/>
+                        </a:rPr>
+                        <a:t>Condition</a:t>
+                      </a:r>
+                      <a:endParaRPr lang="en-US" sz="1400" dirty="0">
+                        <a:latin typeface="Times New Roman" charset="0"/>
+                        <a:ea typeface="Times New Roman" charset="0"/>
+                        <a:cs typeface="Times New Roman" charset="0"/>
+                      </a:endParaRPr>
+                    </a:p>
+                  </a:txBody>
+                  <a:tcPr marL="73152" marR="73152" marT="36576" marB="36576" anchor="b">
+                    <a:lnL w="0" cap="flat" cmpd="sng" algn="ctr">
+                      <a:noFill/>
+                    </a:lnL>
+                    <a:lnR w="0" cap="flat" cmpd="sng" algn="ctr">
+                      <a:noFill/>
                     </a:lnR>
-                    <a:lnT w="6350" cap="flat" cmpd="sng" algn="ctr">
+                    <a:lnT w="0" cap="flat" cmpd="sng" algn="ctr">
+                      <a:noFill/>
+                    </a:lnT>
+                    <a:lnB w="19050" cap="flat" cmpd="sng" algn="ctr">
                       <a:solidFill>
-                        <a:srgbClr val="D3DCE2"/>
+                        <a:srgbClr val="1F6F8B"/>
                       </a:solidFill>
                       <a:prstDash val="solid"/>
                       <a:round/>
                       <a:headEnd type="none" w="med" len="med"/>
                       <a:tailEnd type="none" w="med" len="med"/>
+                    </a:lnB>
+                  </a:tcPr>
+                </a:tc>
+                <a:tc>
+                  <a:txBody>
+                    <a:bodyPr/>
+                    <a:lstStyle/>
+                    <a:p>
+                      <a:pPr indent="0" marL="0">
+                        <a:buNone/>
+                      </a:pPr>
+                      <a:r>
+                        <a:rPr lang="en-US" sz="1400" b="1" dirty="0">
+                          <a:solidFill>
+                            <a:schemeClr val="accent1"/>
+                          </a:solidFill>
+                          <a:latin typeface="Times New Roman" pitchFamily="34" charset="0"/>
+                          <a:ea typeface="Times New Roman" pitchFamily="34" charset="-122"/>
+                          <a:cs typeface="Times New Roman" pitchFamily="34" charset="-120"/>
+                        </a:rPr>
+                        <a:t>References</a:t>
+                      </a:r>
+                      <a:endParaRPr lang="en-US" sz="1400" dirty="0">
+                        <a:latin typeface="Times New Roman" charset="0"/>
+                        <a:ea typeface="Times New Roman" charset="0"/>
+                        <a:cs typeface="Times New Roman" charset="0"/>
+                      </a:endParaRPr>
+                    </a:p>
+                  </a:txBody>
+                  <a:tcPr marL="73152" marR="73152" marT="36576" marB="36576" anchor="b">
+                    <a:lnL w="0" cap="flat" cmpd="sng" algn="ctr">
+                      <a:noFill/>
+                    </a:lnL>
+                    <a:lnR w="0" cap="flat" cmpd="sng" algn="ctr">
+                      <a:noFill/>
+                    </a:lnR>
+                    <a:lnT w="0" cap="flat" cmpd="sng" algn="ctr">
+                      <a:noFill/>
                     </a:lnT>
-                    <a:lnB w="6350" cap="flat" cmpd="sng" algn="ctr">
+                    <a:lnB w="19050" cap="flat" cmpd="sng" algn="ctr">
+                      <a:solidFill>
+                        <a:srgbClr val="1F6F8B"/>
+                      </a:solidFill>
+                      <a:prstDash val="solid"/>
+                      <a:round/>
+                      <a:headEnd type="none" w="med" len="med"/>
+                      <a:tailEnd type="none" w="med" len="med"/>
+                    </a:lnB>
+                  </a:tcPr>
+                </a:tc>
+              </a:tr>
+              <a:tr h="786384">
+                <a:tc>
+                  <a:txBody>
+                    <a:bodyPr/>
+                    <a:lstStyle/>
+                    <a:p>
+                      <a:pPr indent="0" marL="0">
+                        <a:buNone/>
+                      </a:pPr>
+                      <a:r>
+                        <a:rPr lang="en-US" sz="1400" b="1" dirty="0">
+                          <a:solidFill>
+                            <a:schemeClr val="tx2"/>
+                          </a:solidFill>
+                          <a:latin typeface="Times New Roman" pitchFamily="34" charset="0"/>
+                          <a:ea typeface="Times New Roman" pitchFamily="34" charset="-122"/>
+                          <a:cs typeface="Times New Roman" pitchFamily="34" charset="-120"/>
+                        </a:rPr>
+                        <a:t>Boreal &amp; temperate forest</a:t>
+                      </a:r>
+                      <a:endParaRPr lang="en-US" sz="1400" dirty="0">
+                        <a:latin typeface="Times New Roman" charset="0"/>
+                        <a:ea typeface="Times New Roman" charset="0"/>
+                        <a:cs typeface="Times New Roman" charset="0"/>
+                      </a:endParaRPr>
+                    </a:p>
+                  </a:txBody>
+                  <a:tcPr marL="73152" marR="73152" marT="36576" marB="36576" anchor="ctr">
+                    <a:lnL w="0" cap="flat" cmpd="sng" algn="ctr">
+                      <a:noFill/>
+                    </a:lnL>
+                    <a:lnR w="0" cap="flat" cmpd="sng" algn="ctr">
+                      <a:noFill/>
+                    </a:lnR>
+                    <a:lnT w="0" cap="flat" cmpd="sng" algn="ctr">
+                      <a:noFill/>
+                    </a:lnT>
+                    <a:lnB w="9525" cap="flat" cmpd="sng" algn="ctr">
                       <a:solidFill>
                         <a:srgbClr val="D3DCE2"/>
                       </a:solidFill>
@@ -1297,9 +1469,6 @@
                       <a:headEnd type="none" w="med" len="med"/>
                       <a:tailEnd type="none" w="med" len="med"/>
                     </a:lnB>
-                    <a:solidFill>
-                      <a:srgbClr val="16384A"/>
-                    </a:solidFill>
                   </a:tcPr>
                 </a:tc>
                 <a:tc>
@@ -1311,15 +1480,36 @@
                         <a:buNone/>
                       </a:pPr>
                       <a:r>
-                        <a:rPr lang="en-US" sz="1400" b="1" dirty="0">
-                          <a:solidFill>
-                            <a:srgbClr val="FFFFFF"/>
-                          </a:solidFill>
-                          <a:latin typeface="Times New Roman" pitchFamily="34" charset="0"/>
-                          <a:ea typeface="Times New Roman" pitchFamily="34" charset="-122"/>
-                          <a:cs typeface="Times New Roman" pitchFamily="34" charset="-120"/>
-                        </a:rPr>
-                        <a:t>Aerosol impact</a:t>
+                        <a:rPr lang="en-US" sz="1400" dirty="0">
+                          <a:solidFill>
+                            <a:srgbClr val="1A1F24"/>
+                          </a:solidFill>
+                          <a:latin typeface="Times New Roman" pitchFamily="34" charset="0"/>
+                          <a:ea typeface="Times New Roman" pitchFamily="34" charset="-122"/>
+                          <a:cs typeface="Times New Roman" pitchFamily="34" charset="-120"/>
+                        </a:rPr>
+                        <a:t>GPP +6–14%</a:t>
+                      </a:r>
+                      <a:endParaRPr lang="en-US" sz="1400" dirty="0">
+                        <a:latin typeface="Times New Roman" charset="0"/>
+                        <a:ea typeface="Times New Roman" charset="0"/>
+                        <a:cs typeface="Times New Roman" charset="0"/>
+                      </a:endParaRPr>
+                    </a:p>
+                    <a:p>
+                      <a:pPr indent="0" marL="0">
+                        <a:buNone/>
+                      </a:pPr>
+                      <a:r>
+                        <a:rPr lang="en-US" sz="1400" dirty="0">
+                          <a:solidFill>
+                            <a:srgbClr val="1A1F24"/>
+                          </a:solidFill>
+                          <a:latin typeface="Times New Roman" pitchFamily="34" charset="0"/>
+                          <a:ea typeface="Times New Roman" pitchFamily="34" charset="-122"/>
+                          <a:cs typeface="Times New Roman" pitchFamily="34" charset="-120"/>
+                        </a:rPr>
+                        <a:t>Noon GPP +23% after Pinatubo</a:t>
                       </a:r>
                       <a:endParaRPr lang="en-US" sz="1400" dirty="0">
                         <a:latin typeface="Times New Roman" charset="0"/>
@@ -1328,35 +1518,17 @@
                       </a:endParaRPr>
                     </a:p>
                   </a:txBody>
-                  <a:tcPr marL="64008" marR="64008" marT="9144" marB="9144" anchor="ctr">
-                    <a:lnL w="6350" cap="flat" cmpd="sng" algn="ctr">
-                      <a:solidFill>
-                        <a:srgbClr val="D3DCE2"/>
-                      </a:solidFill>
-                      <a:prstDash val="solid"/>
-                      <a:round/>
-                      <a:headEnd type="none" w="med" len="med"/>
-                      <a:tailEnd type="none" w="med" len="med"/>
+                  <a:tcPr marL="73152" marR="73152" marT="36576" marB="36576" anchor="ctr">
+                    <a:lnL w="0" cap="flat" cmpd="sng" algn="ctr">
+                      <a:noFill/>
                     </a:lnL>
-                    <a:lnR w="6350" cap="flat" cmpd="sng" algn="ctr">
-                      <a:solidFill>
-                        <a:srgbClr val="D3DCE2"/>
-                      </a:solidFill>
-                      <a:prstDash val="solid"/>
-                      <a:round/>
-                      <a:headEnd type="none" w="med" len="med"/>
-                      <a:tailEnd type="none" w="med" len="med"/>
+                    <a:lnR w="0" cap="flat" cmpd="sng" algn="ctr">
+                      <a:noFill/>
                     </a:lnR>
-                    <a:lnT w="6350" cap="flat" cmpd="sng" algn="ctr">
-                      <a:solidFill>
-                        <a:srgbClr val="D3DCE2"/>
-                      </a:solidFill>
-                      <a:prstDash val="solid"/>
-                      <a:round/>
-                      <a:headEnd type="none" w="med" len="med"/>
-                      <a:tailEnd type="none" w="med" len="med"/>
+                    <a:lnT w="0" cap="flat" cmpd="sng" algn="ctr">
+                      <a:noFill/>
                     </a:lnT>
-                    <a:lnB w="6350" cap="flat" cmpd="sng" algn="ctr">
+                    <a:lnB w="9525" cap="flat" cmpd="sng" algn="ctr">
                       <a:solidFill>
                         <a:srgbClr val="D3DCE2"/>
                       </a:solidFill>
@@ -1365,9 +1537,6 @@
                       <a:headEnd type="none" w="med" len="med"/>
                       <a:tailEnd type="none" w="med" len="med"/>
                     </a:lnB>
-                    <a:solidFill>
-                      <a:srgbClr val="16384A"/>
-                    </a:solidFill>
                   </a:tcPr>
                 </a:tc>
                 <a:tc>
@@ -1381,13 +1550,24 @@
                       <a:r>
                         <a:rPr lang="en-US" sz="1400" b="1" dirty="0">
                           <a:solidFill>
-                            <a:srgbClr val="FFFFFF"/>
-                          </a:solidFill>
-                          <a:latin typeface="Times New Roman" pitchFamily="34" charset="0"/>
-                          <a:ea typeface="Times New Roman" pitchFamily="34" charset="-122"/>
-                          <a:cs typeface="Times New Roman" pitchFamily="34" charset="-120"/>
-                        </a:rPr>
-                        <a:t>Condition for positive or negative effect</a:t>
+                            <a:schemeClr val="accent3"/>
+                          </a:solidFill>
+                          <a:latin typeface="Times New Roman" pitchFamily="34" charset="0"/>
+                          <a:ea typeface="Times New Roman" pitchFamily="34" charset="-122"/>
+                          <a:cs typeface="Times New Roman" pitchFamily="34" charset="-120"/>
+                        </a:rPr>
+                        <a:t>Positive</a:t>
+                      </a:r>
+                      <a:r>
+                        <a:rPr lang="en-US" sz="1400" dirty="0">
+                          <a:solidFill>
+                            <a:srgbClr val="1A1F24"/>
+                          </a:solidFill>
+                          <a:latin typeface="Times New Roman" pitchFamily="34" charset="0"/>
+                          <a:ea typeface="Times New Roman" pitchFamily="34" charset="-122"/>
+                          <a:cs typeface="Times New Roman" pitchFamily="34" charset="-120"/>
+                        </a:rPr>
+                        <a:t> under low aerosol load; diffuse fraction 0.11 → 0.2–0.27</a:t>
                       </a:r>
                       <a:endParaRPr lang="en-US" sz="1400" dirty="0">
                         <a:latin typeface="Times New Roman" charset="0"/>
@@ -1396,35 +1576,17 @@
                       </a:endParaRPr>
                     </a:p>
                   </a:txBody>
-                  <a:tcPr marL="64008" marR="64008" marT="9144" marB="9144" anchor="ctr">
-                    <a:lnL w="6350" cap="flat" cmpd="sng" algn="ctr">
-                      <a:solidFill>
-                        <a:srgbClr val="D3DCE2"/>
-                      </a:solidFill>
-                      <a:prstDash val="solid"/>
-                      <a:round/>
-                      <a:headEnd type="none" w="med" len="med"/>
-                      <a:tailEnd type="none" w="med" len="med"/>
+                  <a:tcPr marL="73152" marR="73152" marT="36576" marB="36576" anchor="ctr">
+                    <a:lnL w="0" cap="flat" cmpd="sng" algn="ctr">
+                      <a:noFill/>
                     </a:lnL>
-                    <a:lnR w="6350" cap="flat" cmpd="sng" algn="ctr">
-                      <a:solidFill>
-                        <a:srgbClr val="D3DCE2"/>
-                      </a:solidFill>
-                      <a:prstDash val="solid"/>
-                      <a:round/>
-                      <a:headEnd type="none" w="med" len="med"/>
-                      <a:tailEnd type="none" w="med" len="med"/>
+                    <a:lnR w="0" cap="flat" cmpd="sng" algn="ctr">
+                      <a:noFill/>
                     </a:lnR>
-                    <a:lnT w="6350" cap="flat" cmpd="sng" algn="ctr">
-                      <a:solidFill>
-                        <a:srgbClr val="D3DCE2"/>
-                      </a:solidFill>
-                      <a:prstDash val="solid"/>
-                      <a:round/>
-                      <a:headEnd type="none" w="med" len="med"/>
-                      <a:tailEnd type="none" w="med" len="med"/>
+                    <a:lnT w="0" cap="flat" cmpd="sng" algn="ctr">
+                      <a:noFill/>
                     </a:lnT>
-                    <a:lnB w="6350" cap="flat" cmpd="sng" algn="ctr">
+                    <a:lnB w="9525" cap="flat" cmpd="sng" algn="ctr">
                       <a:solidFill>
                         <a:srgbClr val="D3DCE2"/>
                       </a:solidFill>
@@ -1433,9 +1595,6 @@
                       <a:headEnd type="none" w="med" len="med"/>
                       <a:tailEnd type="none" w="med" len="med"/>
                     </a:lnB>
-                    <a:solidFill>
-                      <a:srgbClr val="16384A"/>
-                    </a:solidFill>
                   </a:tcPr>
                 </a:tc>
                 <a:tc>
@@ -1447,15 +1606,36 @@
                         <a:buNone/>
                       </a:pPr>
                       <a:r>
-                        <a:rPr lang="en-US" sz="1400" b="1" dirty="0">
-                          <a:solidFill>
-                            <a:srgbClr val="FFFFFF"/>
-                          </a:solidFill>
-                          <a:latin typeface="Times New Roman" pitchFamily="34" charset="0"/>
-                          <a:ea typeface="Times New Roman" pitchFamily="34" charset="-122"/>
-                          <a:cs typeface="Times New Roman" pitchFamily="34" charset="-120"/>
-                        </a:rPr>
-                        <a:t>References</a:t>
+                        <a:rPr lang="en-US" sz="1400" i="1" dirty="0">
+                          <a:solidFill>
+                            <a:schemeClr val="accent1"/>
+                          </a:solidFill>
+                          <a:latin typeface="Times New Roman" pitchFamily="34" charset="0"/>
+                          <a:ea typeface="Times New Roman" pitchFamily="34" charset="-122"/>
+                          <a:cs typeface="Times New Roman" pitchFamily="34" charset="-120"/>
+                        </a:rPr>
+                        <a:t>Ezhova et al., 2018</a:t>
+                      </a:r>
+                      <a:endParaRPr lang="en-US" sz="1400" dirty="0">
+                        <a:latin typeface="Times New Roman" charset="0"/>
+                        <a:ea typeface="Times New Roman" charset="0"/>
+                        <a:cs typeface="Times New Roman" charset="0"/>
+                      </a:endParaRPr>
+                    </a:p>
+                    <a:p>
+                      <a:pPr indent="0" marL="0">
+                        <a:buNone/>
+                      </a:pPr>
+                      <a:r>
+                        <a:rPr lang="en-US" sz="1400" i="1" dirty="0">
+                          <a:solidFill>
+                            <a:schemeClr val="accent1"/>
+                          </a:solidFill>
+                          <a:latin typeface="Times New Roman" pitchFamily="34" charset="0"/>
+                          <a:ea typeface="Times New Roman" pitchFamily="34" charset="-122"/>
+                          <a:cs typeface="Times New Roman" pitchFamily="34" charset="-120"/>
+                        </a:rPr>
+                        <a:t>Gu et al., 2003</a:t>
                       </a:r>
                       <a:endParaRPr lang="en-US" sz="1400" dirty="0">
                         <a:latin typeface="Times New Roman" charset="0"/>
@@ -1464,35 +1644,17 @@
                       </a:endParaRPr>
                     </a:p>
                   </a:txBody>
-                  <a:tcPr marL="64008" marR="64008" marT="9144" marB="9144" anchor="ctr">
-                    <a:lnL w="6350" cap="flat" cmpd="sng" algn="ctr">
-                      <a:solidFill>
-                        <a:srgbClr val="D3DCE2"/>
-                      </a:solidFill>
-                      <a:prstDash val="solid"/>
-                      <a:round/>
-                      <a:headEnd type="none" w="med" len="med"/>
-                      <a:tailEnd type="none" w="med" len="med"/>
+                  <a:tcPr marL="73152" marR="73152" marT="36576" marB="36576" anchor="ctr">
+                    <a:lnL w="0" cap="flat" cmpd="sng" algn="ctr">
+                      <a:noFill/>
                     </a:lnL>
-                    <a:lnR w="6350" cap="flat" cmpd="sng" algn="ctr">
-                      <a:solidFill>
-                        <a:srgbClr val="D3DCE2"/>
-                      </a:solidFill>
-                      <a:prstDash val="solid"/>
-                      <a:round/>
-                      <a:headEnd type="none" w="med" len="med"/>
-                      <a:tailEnd type="none" w="med" len="med"/>
+                    <a:lnR w="0" cap="flat" cmpd="sng" algn="ctr">
+                      <a:noFill/>
                     </a:lnR>
-                    <a:lnT w="6350" cap="flat" cmpd="sng" algn="ctr">
-                      <a:solidFill>
-                        <a:srgbClr val="D3DCE2"/>
-                      </a:solidFill>
-                      <a:prstDash val="solid"/>
-                      <a:round/>
-                      <a:headEnd type="none" w="med" len="med"/>
-                      <a:tailEnd type="none" w="med" len="med"/>
+                    <a:lnT w="0" cap="flat" cmpd="sng" algn="ctr">
+                      <a:noFill/>
                     </a:lnT>
-                    <a:lnB w="6350" cap="flat" cmpd="sng" algn="ctr">
+                    <a:lnB w="9525" cap="flat" cmpd="sng" algn="ctr">
                       <a:solidFill>
                         <a:srgbClr val="D3DCE2"/>
                       </a:solidFill>
@@ -1501,13 +1663,10 @@
                       <a:headEnd type="none" w="med" len="med"/>
                       <a:tailEnd type="none" w="med" len="med"/>
                     </a:lnB>
-                    <a:solidFill>
-                      <a:srgbClr val="16384A"/>
-                    </a:solidFill>
                   </a:tcPr>
                 </a:tc>
               </a:tr>
-              <a:tr h="713232">
+              <a:tr h="786384">
                 <a:tc>
                   <a:txBody>
                     <a:bodyPr/>
@@ -1525,7 +1684,7 @@
                           <a:ea typeface="Times New Roman" pitchFamily="34" charset="-122"/>
                           <a:cs typeface="Times New Roman" pitchFamily="34" charset="-120"/>
                         </a:rPr>
-                        <a:t>Boreal &amp; temperate forest</a:t>
+                        <a:t>Tropical forest (Amazon)</a:t>
                       </a:r>
                       <a:endParaRPr lang="en-US" sz="1400" dirty="0">
                         <a:latin typeface="Times New Roman" charset="0"/>
@@ -1534,35 +1693,17 @@
                       </a:endParaRPr>
                     </a:p>
                   </a:txBody>
-                  <a:tcPr marL="64008" marR="64008" marT="9144" marB="9144" anchor="ctr">
-                    <a:lnL w="6350" cap="flat" cmpd="sng" algn="ctr">
-                      <a:solidFill>
-                        <a:srgbClr val="D3DCE2"/>
-                      </a:solidFill>
-                      <a:prstDash val="solid"/>
-                      <a:round/>
-                      <a:headEnd type="none" w="med" len="med"/>
-                      <a:tailEnd type="none" w="med" len="med"/>
+                  <a:tcPr marL="73152" marR="73152" marT="36576" marB="36576" anchor="ctr">
+                    <a:lnL w="0" cap="flat" cmpd="sng" algn="ctr">
+                      <a:noFill/>
                     </a:lnL>
-                    <a:lnR w="6350" cap="flat" cmpd="sng" algn="ctr">
-                      <a:solidFill>
-                        <a:srgbClr val="D3DCE2"/>
-                      </a:solidFill>
-                      <a:prstDash val="solid"/>
-                      <a:round/>
-                      <a:headEnd type="none" w="med" len="med"/>
-                      <a:tailEnd type="none" w="med" len="med"/>
+                    <a:lnR w="0" cap="flat" cmpd="sng" algn="ctr">
+                      <a:noFill/>
                     </a:lnR>
-                    <a:lnT w="6350" cap="flat" cmpd="sng" algn="ctr">
-                      <a:solidFill>
-                        <a:srgbClr val="D3DCE2"/>
-                      </a:solidFill>
-                      <a:prstDash val="solid"/>
-                      <a:round/>
-                      <a:headEnd type="none" w="med" len="med"/>
-                      <a:tailEnd type="none" w="med" len="med"/>
+                    <a:lnT w="0" cap="flat" cmpd="sng" algn="ctr">
+                      <a:noFill/>
                     </a:lnT>
-                    <a:lnB w="6350" cap="flat" cmpd="sng" algn="ctr">
+                    <a:lnB w="9525" cap="flat" cmpd="sng" algn="ctr">
                       <a:solidFill>
                         <a:srgbClr val="D3DCE2"/>
                       </a:solidFill>
@@ -1571,9 +1712,6 @@
                       <a:headEnd type="none" w="med" len="med"/>
                       <a:tailEnd type="none" w="med" len="med"/>
                     </a:lnB>
-                    <a:solidFill>
-                      <a:srgbClr val="EDF2F5"/>
-                    </a:solidFill>
                   </a:tcPr>
                 </a:tc>
                 <a:tc>
@@ -1587,13 +1725,34 @@
                       <a:r>
                         <a:rPr lang="en-US" sz="1400" dirty="0">
                           <a:solidFill>
-                            <a:srgbClr val="000000"/>
-                          </a:solidFill>
-                          <a:latin typeface="Times New Roman" pitchFamily="34" charset="0"/>
-                          <a:ea typeface="Times New Roman" pitchFamily="34" charset="-122"/>
-                          <a:cs typeface="Times New Roman" pitchFamily="34" charset="-120"/>
-                        </a:rPr>
-                        <a:t>GPP +6 to 14% (boreal); noon GPP +23% after Pinatubo</a:t>
+                            <a:srgbClr val="1A1F24"/>
+                          </a:solidFill>
+                          <a:latin typeface="Times New Roman" pitchFamily="34" charset="0"/>
+                          <a:ea typeface="Times New Roman" pitchFamily="34" charset="-122"/>
+                          <a:cs typeface="Times New Roman" pitchFamily="34" charset="-120"/>
+                        </a:rPr>
+                        <a:t>NEE +8.4–16%</a:t>
+                      </a:r>
+                      <a:endParaRPr lang="en-US" sz="1400" dirty="0">
+                        <a:latin typeface="Times New Roman" charset="0"/>
+                        <a:ea typeface="Times New Roman" charset="0"/>
+                        <a:cs typeface="Times New Roman" charset="0"/>
+                      </a:endParaRPr>
+                    </a:p>
+                    <a:p>
+                      <a:pPr indent="0" marL="0">
+                        <a:buNone/>
+                      </a:pPr>
+                      <a:r>
+                        <a:rPr lang="en-US" sz="1400" dirty="0">
+                          <a:solidFill>
+                            <a:srgbClr val="1A1F24"/>
+                          </a:solidFill>
+                          <a:latin typeface="Times New Roman" pitchFamily="34" charset="0"/>
+                          <a:ea typeface="Times New Roman" pitchFamily="34" charset="-122"/>
+                          <a:cs typeface="Times New Roman" pitchFamily="34" charset="-120"/>
+                        </a:rPr>
+                        <a:t>NPP +1.4–2.8% (fire aerosol)</a:t>
                       </a:r>
                       <a:endParaRPr lang="en-US" sz="1400" dirty="0">
                         <a:latin typeface="Times New Roman" charset="0"/>
@@ -1602,35 +1761,17 @@
                       </a:endParaRPr>
                     </a:p>
                   </a:txBody>
-                  <a:tcPr marL="64008" marR="64008" marT="9144" marB="9144" anchor="ctr">
-                    <a:lnL w="6350" cap="flat" cmpd="sng" algn="ctr">
-                      <a:solidFill>
-                        <a:srgbClr val="D3DCE2"/>
-                      </a:solidFill>
-                      <a:prstDash val="solid"/>
-                      <a:round/>
-                      <a:headEnd type="none" w="med" len="med"/>
-                      <a:tailEnd type="none" w="med" len="med"/>
+                  <a:tcPr marL="73152" marR="73152" marT="36576" marB="36576" anchor="ctr">
+                    <a:lnL w="0" cap="flat" cmpd="sng" algn="ctr">
+                      <a:noFill/>
                     </a:lnL>
-                    <a:lnR w="6350" cap="flat" cmpd="sng" algn="ctr">
-                      <a:solidFill>
-                        <a:srgbClr val="D3DCE2"/>
-                      </a:solidFill>
-                      <a:prstDash val="solid"/>
-                      <a:round/>
-                      <a:headEnd type="none" w="med" len="med"/>
-                      <a:tailEnd type="none" w="med" len="med"/>
+                    <a:lnR w="0" cap="flat" cmpd="sng" algn="ctr">
+                      <a:noFill/>
                     </a:lnR>
-                    <a:lnT w="6350" cap="flat" cmpd="sng" algn="ctr">
-                      <a:solidFill>
-                        <a:srgbClr val="D3DCE2"/>
-                      </a:solidFill>
-                      <a:prstDash val="solid"/>
-                      <a:round/>
-                      <a:headEnd type="none" w="med" len="med"/>
-                      <a:tailEnd type="none" w="med" len="med"/>
+                    <a:lnT w="0" cap="flat" cmpd="sng" algn="ctr">
+                      <a:noFill/>
                     </a:lnT>
-                    <a:lnB w="6350" cap="flat" cmpd="sng" algn="ctr">
+                    <a:lnB w="9525" cap="flat" cmpd="sng" algn="ctr">
                       <a:solidFill>
                         <a:srgbClr val="D3DCE2"/>
                       </a:solidFill>
@@ -1639,9 +1780,6 @@
                       <a:headEnd type="none" w="med" len="med"/>
                       <a:tailEnd type="none" w="med" len="med"/>
                     </a:lnB>
-                    <a:solidFill>
-                      <a:srgbClr val="EDF2F5"/>
-                    </a:solidFill>
                   </a:tcPr>
                 </a:tc>
                 <a:tc>
@@ -1655,7 +1793,7 @@
                       <a:r>
                         <a:rPr lang="en-US" sz="1400" b="1" dirty="0">
                           <a:solidFill>
-                            <a:srgbClr val="000000"/>
+                            <a:schemeClr val="accent3"/>
                           </a:solidFill>
                           <a:latin typeface="Times New Roman" pitchFamily="34" charset="0"/>
                           <a:ea typeface="Times New Roman" pitchFamily="34" charset="-122"/>
@@ -1666,13 +1804,35 @@
                       <a:r>
                         <a:rPr lang="en-US" sz="1400" dirty="0">
                           <a:solidFill>
-                            <a:srgbClr val="000000"/>
-                          </a:solidFill>
-                          <a:latin typeface="Times New Roman" pitchFamily="34" charset="0"/>
-                          <a:ea typeface="Times New Roman" pitchFamily="34" charset="-122"/>
-                          <a:cs typeface="Times New Roman" pitchFamily="34" charset="-120"/>
-                        </a:rPr>
-                        <a:t> at moderate AOD (diffuse fraction 0.2–0.27); negligible if LAI &lt; 3</a:t>
+                            <a:srgbClr val="1A1F24"/>
+                          </a:solidFill>
+                          <a:latin typeface="Times New Roman" pitchFamily="34" charset="0"/>
+                          <a:ea typeface="Times New Roman" pitchFamily="34" charset="-122"/>
+                          <a:cs typeface="Times New Roman" pitchFamily="34" charset="-120"/>
+                        </a:rPr>
+                        <a:t> at AOD 0.83–1.26; </a:t>
+                      </a:r>
+                      <a:r>
+                        <a:rPr lang="en-US" sz="1400" b="1" dirty="0">
+                          <a:solidFill>
+                            <a:schemeClr val="accent5"/>
+                          </a:solidFill>
+                          <a:latin typeface="Times New Roman" pitchFamily="34" charset="0"/>
+                          <a:ea typeface="Times New Roman" pitchFamily="34" charset="-122"/>
+                          <a:cs typeface="Times New Roman" pitchFamily="34" charset="-120"/>
+                        </a:rPr>
+                        <a:t>Negative</a:t>
+                      </a:r>
+                      <a:r>
+                        <a:rPr lang="en-US" sz="1400" dirty="0">
+                          <a:solidFill>
+                            <a:srgbClr val="1A1F24"/>
+                          </a:solidFill>
+                          <a:latin typeface="Times New Roman" pitchFamily="34" charset="0"/>
+                          <a:ea typeface="Times New Roman" pitchFamily="34" charset="-122"/>
+                          <a:cs typeface="Times New Roman" pitchFamily="34" charset="-120"/>
+                        </a:rPr>
+                        <a:t> above AOD 1.7</a:t>
                       </a:r>
                       <a:endParaRPr lang="en-US" sz="1400" dirty="0">
                         <a:latin typeface="Times New Roman" charset="0"/>
@@ -1681,35 +1841,17 @@
                       </a:endParaRPr>
                     </a:p>
                   </a:txBody>
-                  <a:tcPr marL="64008" marR="64008" marT="9144" marB="9144" anchor="ctr">
-                    <a:lnL w="6350" cap="flat" cmpd="sng" algn="ctr">
-                      <a:solidFill>
-                        <a:srgbClr val="D3DCE2"/>
-                      </a:solidFill>
-                      <a:prstDash val="solid"/>
-                      <a:round/>
-                      <a:headEnd type="none" w="med" len="med"/>
-                      <a:tailEnd type="none" w="med" len="med"/>
+                  <a:tcPr marL="73152" marR="73152" marT="36576" marB="36576" anchor="ctr">
+                    <a:lnL w="0" cap="flat" cmpd="sng" algn="ctr">
+                      <a:noFill/>
                     </a:lnL>
-                    <a:lnR w="6350" cap="flat" cmpd="sng" algn="ctr">
-                      <a:solidFill>
-                        <a:srgbClr val="D3DCE2"/>
-                      </a:solidFill>
-                      <a:prstDash val="solid"/>
-                      <a:round/>
-                      <a:headEnd type="none" w="med" len="med"/>
-                      <a:tailEnd type="none" w="med" len="med"/>
+                    <a:lnR w="0" cap="flat" cmpd="sng" algn="ctr">
+                      <a:noFill/>
                     </a:lnR>
-                    <a:lnT w="6350" cap="flat" cmpd="sng" algn="ctr">
-                      <a:solidFill>
-                        <a:srgbClr val="D3DCE2"/>
-                      </a:solidFill>
-                      <a:prstDash val="solid"/>
-                      <a:round/>
-                      <a:headEnd type="none" w="med" len="med"/>
-                      <a:tailEnd type="none" w="med" len="med"/>
+                    <a:lnT w="0" cap="flat" cmpd="sng" algn="ctr">
+                      <a:noFill/>
                     </a:lnT>
-                    <a:lnB w="6350" cap="flat" cmpd="sng" algn="ctr">
+                    <a:lnB w="9525" cap="flat" cmpd="sng" algn="ctr">
                       <a:solidFill>
                         <a:srgbClr val="D3DCE2"/>
                       </a:solidFill>
@@ -1718,9 +1860,6 @@
                       <a:headEnd type="none" w="med" len="med"/>
                       <a:tailEnd type="none" w="med" len="med"/>
                     </a:lnB>
-                    <a:solidFill>
-                      <a:srgbClr val="EDF2F5"/>
-                    </a:solidFill>
                   </a:tcPr>
                 </a:tc>
                 <a:tc>
@@ -1740,7 +1879,7 @@
                           <a:ea typeface="Times New Roman" pitchFamily="34" charset="-122"/>
                           <a:cs typeface="Times New Roman" pitchFamily="34" charset="-120"/>
                         </a:rPr>
-                        <a:t>Ezhova et al., 2018</a:t>
+                        <a:t>Oliveira et al., 2007</a:t>
                       </a:r>
                       <a:endParaRPr lang="en-US" sz="1400" dirty="0">
                         <a:latin typeface="Times New Roman" charset="0"/>
@@ -1761,28 +1900,7 @@
                           <a:ea typeface="Times New Roman" pitchFamily="34" charset="-122"/>
                           <a:cs typeface="Times New Roman" pitchFamily="34" charset="-120"/>
                         </a:rPr>
-                        <a:t>Gu et al., 2003</a:t>
-                      </a:r>
-                      <a:endParaRPr lang="en-US" sz="1400" dirty="0">
-                        <a:latin typeface="Times New Roman" charset="0"/>
-                        <a:ea typeface="Times New Roman" charset="0"/>
-                        <a:cs typeface="Times New Roman" charset="0"/>
-                      </a:endParaRPr>
-                    </a:p>
-                    <a:p>
-                      <a:pPr indent="0" marL="0">
-                        <a:buNone/>
-                      </a:pPr>
-                      <a:r>
-                        <a:rPr lang="en-US" sz="1400" i="1" dirty="0">
-                          <a:solidFill>
-                            <a:schemeClr val="accent1"/>
-                          </a:solidFill>
-                          <a:latin typeface="Times New Roman" pitchFamily="34" charset="0"/>
-                          <a:ea typeface="Times New Roman" pitchFamily="34" charset="-122"/>
-                          <a:cs typeface="Times New Roman" pitchFamily="34" charset="-120"/>
-                        </a:rPr>
-                        <a:t>Matsui et al., 2008</a:t>
+                        <a:t>Rap et al., 2015</a:t>
                       </a:r>
                       <a:endParaRPr lang="en-US" sz="1400" dirty="0">
                         <a:latin typeface="Times New Roman" charset="0"/>
@@ -1791,35 +1909,17 @@
                       </a:endParaRPr>
                     </a:p>
                   </a:txBody>
-                  <a:tcPr marL="64008" marR="64008" marT="9144" marB="9144" anchor="ctr">
-                    <a:lnL w="6350" cap="flat" cmpd="sng" algn="ctr">
-                      <a:solidFill>
-                        <a:srgbClr val="D3DCE2"/>
-                      </a:solidFill>
-                      <a:prstDash val="solid"/>
-                      <a:round/>
-                      <a:headEnd type="none" w="med" len="med"/>
-                      <a:tailEnd type="none" w="med" len="med"/>
+                  <a:tcPr marL="73152" marR="73152" marT="36576" marB="36576" anchor="ctr">
+                    <a:lnL w="0" cap="flat" cmpd="sng" algn="ctr">
+                      <a:noFill/>
                     </a:lnL>
-                    <a:lnR w="6350" cap="flat" cmpd="sng" algn="ctr">
-                      <a:solidFill>
-                        <a:srgbClr val="D3DCE2"/>
-                      </a:solidFill>
-                      <a:prstDash val="solid"/>
-                      <a:round/>
-                      <a:headEnd type="none" w="med" len="med"/>
-                      <a:tailEnd type="none" w="med" len="med"/>
+                    <a:lnR w="0" cap="flat" cmpd="sng" algn="ctr">
+                      <a:noFill/>
                     </a:lnR>
-                    <a:lnT w="6350" cap="flat" cmpd="sng" algn="ctr">
-                      <a:solidFill>
-                        <a:srgbClr val="D3DCE2"/>
-                      </a:solidFill>
-                      <a:prstDash val="solid"/>
-                      <a:round/>
-                      <a:headEnd type="none" w="med" len="med"/>
-                      <a:tailEnd type="none" w="med" len="med"/>
+                    <a:lnT w="0" cap="flat" cmpd="sng" algn="ctr">
+                      <a:noFill/>
                     </a:lnT>
-                    <a:lnB w="6350" cap="flat" cmpd="sng" algn="ctr">
+                    <a:lnB w="9525" cap="flat" cmpd="sng" algn="ctr">
                       <a:solidFill>
                         <a:srgbClr val="D3DCE2"/>
                       </a:solidFill>
@@ -1828,13 +1928,10 @@
                       <a:headEnd type="none" w="med" len="med"/>
                       <a:tailEnd type="none" w="med" len="med"/>
                     </a:lnB>
-                    <a:solidFill>
-                      <a:srgbClr val="EDF2F5"/>
-                    </a:solidFill>
                   </a:tcPr>
                 </a:tc>
               </a:tr>
-              <a:tr h="914400">
+              <a:tr h="841248">
                 <a:tc>
                   <a:txBody>
                     <a:bodyPr/>
@@ -1852,7 +1949,7 @@
                           <a:ea typeface="Times New Roman" pitchFamily="34" charset="-122"/>
                           <a:cs typeface="Times New Roman" pitchFamily="34" charset="-120"/>
                         </a:rPr>
-                        <a:t>Tropical forest (Amazon)</a:t>
+                        <a:t>Grassland &amp; savanna</a:t>
                       </a:r>
                       <a:endParaRPr lang="en-US" sz="1400" dirty="0">
                         <a:latin typeface="Times New Roman" charset="0"/>
@@ -1861,35 +1958,17 @@
                       </a:endParaRPr>
                     </a:p>
                   </a:txBody>
-                  <a:tcPr marL="64008" marR="64008" marT="9144" marB="9144" anchor="ctr">
-                    <a:lnL w="6350" cap="flat" cmpd="sng" algn="ctr">
-                      <a:solidFill>
-                        <a:srgbClr val="D3DCE2"/>
-                      </a:solidFill>
-                      <a:prstDash val="solid"/>
-                      <a:round/>
-                      <a:headEnd type="none" w="med" len="med"/>
-                      <a:tailEnd type="none" w="med" len="med"/>
+                  <a:tcPr marL="73152" marR="73152" marT="36576" marB="36576" anchor="ctr">
+                    <a:lnL w="0" cap="flat" cmpd="sng" algn="ctr">
+                      <a:noFill/>
                     </a:lnL>
-                    <a:lnR w="6350" cap="flat" cmpd="sng" algn="ctr">
-                      <a:solidFill>
-                        <a:srgbClr val="D3DCE2"/>
-                      </a:solidFill>
-                      <a:prstDash val="solid"/>
-                      <a:round/>
-                      <a:headEnd type="none" w="med" len="med"/>
-                      <a:tailEnd type="none" w="med" len="med"/>
+                    <a:lnR w="0" cap="flat" cmpd="sng" algn="ctr">
+                      <a:noFill/>
                     </a:lnR>
-                    <a:lnT w="6350" cap="flat" cmpd="sng" algn="ctr">
-                      <a:solidFill>
-                        <a:srgbClr val="D3DCE2"/>
-                      </a:solidFill>
-                      <a:prstDash val="solid"/>
-                      <a:round/>
-                      <a:headEnd type="none" w="med" len="med"/>
-                      <a:tailEnd type="none" w="med" len="med"/>
+                    <a:lnT w="0" cap="flat" cmpd="sng" algn="ctr">
+                      <a:noFill/>
                     </a:lnT>
-                    <a:lnB w="6350" cap="flat" cmpd="sng" algn="ctr">
+                    <a:lnB w="9525" cap="flat" cmpd="sng" algn="ctr">
                       <a:solidFill>
                         <a:srgbClr val="D3DCE2"/>
                       </a:solidFill>
@@ -1898,9 +1977,6 @@
                       <a:headEnd type="none" w="med" len="med"/>
                       <a:tailEnd type="none" w="med" len="med"/>
                     </a:lnB>
-                    <a:solidFill>
-                      <a:srgbClr val="FFFFFF"/>
-                    </a:solidFill>
                   </a:tcPr>
                 </a:tc>
                 <a:tc>
@@ -1914,13 +1990,34 @@
                       <a:r>
                         <a:rPr lang="en-US" sz="1400" dirty="0">
                           <a:solidFill>
-                            <a:srgbClr val="000000"/>
-                          </a:solidFill>
-                          <a:latin typeface="Times New Roman" pitchFamily="34" charset="0"/>
-                          <a:ea typeface="Times New Roman" pitchFamily="34" charset="-122"/>
-                          <a:cs typeface="Times New Roman" pitchFamily="34" charset="-120"/>
-                        </a:rPr>
-                        <a:t>NEE +8.4–16%; NPP +1.4–2.8%; lower photosynthetic efficiency under heavy smoke</a:t>
+                            <a:srgbClr val="1A1F24"/>
+                          </a:solidFill>
+                          <a:latin typeface="Times New Roman" pitchFamily="34" charset="0"/>
+                          <a:ea typeface="Times New Roman" pitchFamily="34" charset="-122"/>
+                          <a:cs typeface="Times New Roman" pitchFamily="34" charset="-120"/>
+                        </a:rPr>
+                        <a:t>Grassland uptake fell</a:t>
+                      </a:r>
+                      <a:endParaRPr lang="en-US" sz="1400" dirty="0">
+                        <a:latin typeface="Times New Roman" charset="0"/>
+                        <a:ea typeface="Times New Roman" charset="0"/>
+                        <a:cs typeface="Times New Roman" charset="0"/>
+                      </a:endParaRPr>
+                    </a:p>
+                    <a:p>
+                      <a:pPr indent="0" marL="0">
+                        <a:buNone/>
+                      </a:pPr>
+                      <a:r>
+                        <a:rPr lang="en-US" sz="1400" dirty="0">
+                          <a:solidFill>
+                            <a:srgbClr val="1A1F24"/>
+                          </a:solidFill>
+                          <a:latin typeface="Times New Roman" pitchFamily="34" charset="0"/>
+                          <a:ea typeface="Times New Roman" pitchFamily="34" charset="-122"/>
+                          <a:cs typeface="Times New Roman" pitchFamily="34" charset="-120"/>
+                        </a:rPr>
+                        <a:t>Savanna: no significant change</a:t>
                       </a:r>
                       <a:endParaRPr lang="en-US" sz="1400" dirty="0">
                         <a:latin typeface="Times New Roman" charset="0"/>
@@ -1929,35 +2026,17 @@
                       </a:endParaRPr>
                     </a:p>
                   </a:txBody>
-                  <a:tcPr marL="64008" marR="64008" marT="9144" marB="9144" anchor="ctr">
-                    <a:lnL w="6350" cap="flat" cmpd="sng" algn="ctr">
-                      <a:solidFill>
-                        <a:srgbClr val="D3DCE2"/>
-                      </a:solidFill>
-                      <a:prstDash val="solid"/>
-                      <a:round/>
-                      <a:headEnd type="none" w="med" len="med"/>
-                      <a:tailEnd type="none" w="med" len="med"/>
+                  <a:tcPr marL="73152" marR="73152" marT="36576" marB="36576" anchor="ctr">
+                    <a:lnL w="0" cap="flat" cmpd="sng" algn="ctr">
+                      <a:noFill/>
                     </a:lnL>
-                    <a:lnR w="6350" cap="flat" cmpd="sng" algn="ctr">
-                      <a:solidFill>
-                        <a:srgbClr val="D3DCE2"/>
-                      </a:solidFill>
-                      <a:prstDash val="solid"/>
-                      <a:round/>
-                      <a:headEnd type="none" w="med" len="med"/>
-                      <a:tailEnd type="none" w="med" len="med"/>
+                    <a:lnR w="0" cap="flat" cmpd="sng" algn="ctr">
+                      <a:noFill/>
                     </a:lnR>
-                    <a:lnT w="6350" cap="flat" cmpd="sng" algn="ctr">
-                      <a:solidFill>
-                        <a:srgbClr val="D3DCE2"/>
-                      </a:solidFill>
-                      <a:prstDash val="solid"/>
-                      <a:round/>
-                      <a:headEnd type="none" w="med" len="med"/>
-                      <a:tailEnd type="none" w="med" len="med"/>
+                    <a:lnT w="0" cap="flat" cmpd="sng" algn="ctr">
+                      <a:noFill/>
                     </a:lnT>
-                    <a:lnB w="6350" cap="flat" cmpd="sng" algn="ctr">
+                    <a:lnB w="9525" cap="flat" cmpd="sng" algn="ctr">
                       <a:solidFill>
                         <a:srgbClr val="D3DCE2"/>
                       </a:solidFill>
@@ -1966,9 +2045,6 @@
                       <a:headEnd type="none" w="med" len="med"/>
                       <a:tailEnd type="none" w="med" len="med"/>
                     </a:lnB>
-                    <a:solidFill>
-                      <a:srgbClr val="FFFFFF"/>
-                    </a:solidFill>
                   </a:tcPr>
                 </a:tc>
                 <a:tc>
@@ -1982,46 +2058,24 @@
                       <a:r>
                         <a:rPr lang="en-US" sz="1400" b="1" dirty="0">
                           <a:solidFill>
-                            <a:srgbClr val="000000"/>
-                          </a:solidFill>
-                          <a:latin typeface="Times New Roman" pitchFamily="34" charset="0"/>
-                          <a:ea typeface="Times New Roman" pitchFamily="34" charset="-122"/>
-                          <a:cs typeface="Times New Roman" pitchFamily="34" charset="-120"/>
-                        </a:rPr>
-                        <a:t>Positive</a:t>
+                            <a:schemeClr val="accent5"/>
+                          </a:solidFill>
+                          <a:latin typeface="Times New Roman" pitchFamily="34" charset="0"/>
+                          <a:ea typeface="Times New Roman" pitchFamily="34" charset="-122"/>
+                          <a:cs typeface="Times New Roman" pitchFamily="34" charset="-120"/>
+                        </a:rPr>
+                        <a:t>Negative</a:t>
                       </a:r>
                       <a:r>
                         <a:rPr lang="en-US" sz="1400" dirty="0">
                           <a:solidFill>
-                            <a:srgbClr val="000000"/>
-                          </a:solidFill>
-                          <a:latin typeface="Times New Roman" pitchFamily="34" charset="0"/>
-                          <a:ea typeface="Times New Roman" pitchFamily="34" charset="-122"/>
-                          <a:cs typeface="Times New Roman" pitchFamily="34" charset="-120"/>
-                        </a:rPr>
-                        <a:t> at AOD 0.83–1.26; </a:t>
-                      </a:r>
-                      <a:r>
-                        <a:rPr lang="en-US" sz="1400" b="1" dirty="0">
-                          <a:solidFill>
-                            <a:srgbClr val="000000"/>
-                          </a:solidFill>
-                          <a:latin typeface="Times New Roman" pitchFamily="34" charset="0"/>
-                          <a:ea typeface="Times New Roman" pitchFamily="34" charset="-122"/>
-                          <a:cs typeface="Times New Roman" pitchFamily="34" charset="-120"/>
-                        </a:rPr>
-                        <a:t>negative</a:t>
-                      </a:r>
-                      <a:r>
-                        <a:rPr lang="en-US" sz="1400" dirty="0">
-                          <a:solidFill>
-                            <a:srgbClr val="000000"/>
-                          </a:solidFill>
-                          <a:latin typeface="Times New Roman" pitchFamily="34" charset="0"/>
-                          <a:ea typeface="Times New Roman" pitchFamily="34" charset="-122"/>
-                          <a:cs typeface="Times New Roman" pitchFamily="34" charset="-120"/>
-                        </a:rPr>
-                        <a:t> above AOD 1.7</a:t>
+                            <a:srgbClr val="1A1F24"/>
+                          </a:solidFill>
+                          <a:latin typeface="Times New Roman" pitchFamily="34" charset="0"/>
+                          <a:ea typeface="Times New Roman" pitchFamily="34" charset="-122"/>
+                          <a:cs typeface="Times New Roman" pitchFamily="34" charset="-120"/>
+                        </a:rPr>
+                        <a:t> at AOD &gt; 0.6; negligible gain when LAI &lt; 3</a:t>
                       </a:r>
                       <a:endParaRPr lang="en-US" sz="1400" dirty="0">
                         <a:latin typeface="Times New Roman" charset="0"/>
@@ -2030,35 +2084,17 @@
                       </a:endParaRPr>
                     </a:p>
                   </a:txBody>
-                  <a:tcPr marL="64008" marR="64008" marT="9144" marB="9144" anchor="ctr">
-                    <a:lnL w="6350" cap="flat" cmpd="sng" algn="ctr">
-                      <a:solidFill>
-                        <a:srgbClr val="D3DCE2"/>
-                      </a:solidFill>
-                      <a:prstDash val="solid"/>
-                      <a:round/>
-                      <a:headEnd type="none" w="med" len="med"/>
-                      <a:tailEnd type="none" w="med" len="med"/>
+                  <a:tcPr marL="73152" marR="73152" marT="36576" marB="36576" anchor="ctr">
+                    <a:lnL w="0" cap="flat" cmpd="sng" algn="ctr">
+                      <a:noFill/>
                     </a:lnL>
-                    <a:lnR w="6350" cap="flat" cmpd="sng" algn="ctr">
-                      <a:solidFill>
-                        <a:srgbClr val="D3DCE2"/>
-                      </a:solidFill>
-                      <a:prstDash val="solid"/>
-                      <a:round/>
-                      <a:headEnd type="none" w="med" len="med"/>
-                      <a:tailEnd type="none" w="med" len="med"/>
+                    <a:lnR w="0" cap="flat" cmpd="sng" algn="ctr">
+                      <a:noFill/>
                     </a:lnR>
-                    <a:lnT w="6350" cap="flat" cmpd="sng" algn="ctr">
-                      <a:solidFill>
-                        <a:srgbClr val="D3DCE2"/>
-                      </a:solidFill>
-                      <a:prstDash val="solid"/>
-                      <a:round/>
-                      <a:headEnd type="none" w="med" len="med"/>
-                      <a:tailEnd type="none" w="med" len="med"/>
+                    <a:lnT w="0" cap="flat" cmpd="sng" algn="ctr">
+                      <a:noFill/>
                     </a:lnT>
-                    <a:lnB w="6350" cap="flat" cmpd="sng" algn="ctr">
+                    <a:lnB w="9525" cap="flat" cmpd="sng" algn="ctr">
                       <a:solidFill>
                         <a:srgbClr val="D3DCE2"/>
                       </a:solidFill>
@@ -2067,9 +2103,6 @@
                       <a:headEnd type="none" w="med" len="med"/>
                       <a:tailEnd type="none" w="med" len="med"/>
                     </a:lnB>
-                    <a:solidFill>
-                      <a:srgbClr val="FFFFFF"/>
-                    </a:solidFill>
                   </a:tcPr>
                 </a:tc>
                 <a:tc>
@@ -2089,7 +2122,7 @@
                           <a:ea typeface="Times New Roman" pitchFamily="34" charset="-122"/>
                           <a:cs typeface="Times New Roman" pitchFamily="34" charset="-120"/>
                         </a:rPr>
-                        <a:t>Doughty et al., 2010</a:t>
+                        <a:t>Strada et al., 2015</a:t>
                       </a:r>
                       <a:endParaRPr lang="en-US" sz="1400" dirty="0">
                         <a:latin typeface="Times New Roman" charset="0"/>
@@ -2110,7 +2143,7 @@
                           <a:ea typeface="Times New Roman" pitchFamily="34" charset="-122"/>
                           <a:cs typeface="Times New Roman" pitchFamily="34" charset="-120"/>
                         </a:rPr>
-                        <a:t>Rap et al., 2015</a:t>
+                        <a:t>Matsui et al., 2008</a:t>
                       </a:r>
                       <a:endParaRPr lang="en-US" sz="1400" dirty="0">
                         <a:latin typeface="Times New Roman" charset="0"/>
@@ -2131,28 +2164,7 @@
                           <a:ea typeface="Times New Roman" pitchFamily="34" charset="-122"/>
                           <a:cs typeface="Times New Roman" pitchFamily="34" charset="-120"/>
                         </a:rPr>
-                        <a:t>Oliveira et al., 2007</a:t>
-                      </a:r>
-                      <a:endParaRPr lang="en-US" sz="1400" dirty="0">
-                        <a:latin typeface="Times New Roman" charset="0"/>
-                        <a:ea typeface="Times New Roman" charset="0"/>
-                        <a:cs typeface="Times New Roman" charset="0"/>
-                      </a:endParaRPr>
-                    </a:p>
-                    <a:p>
-                      <a:pPr indent="0" marL="0">
-                        <a:buNone/>
-                      </a:pPr>
-                      <a:r>
-                        <a:rPr lang="en-US" sz="1400" i="1" dirty="0">
-                          <a:solidFill>
-                            <a:schemeClr val="accent1"/>
-                          </a:solidFill>
-                          <a:latin typeface="Times New Roman" pitchFamily="34" charset="0"/>
-                          <a:ea typeface="Times New Roman" pitchFamily="34" charset="-122"/>
-                          <a:cs typeface="Times New Roman" pitchFamily="34" charset="-120"/>
-                        </a:rPr>
-                        <a:t>Cirino et al., 2014</a:t>
+                        <a:t>Kanniah et al., 2010</a:t>
                       </a:r>
                       <a:endParaRPr lang="en-US" sz="1400" dirty="0">
                         <a:latin typeface="Times New Roman" charset="0"/>
@@ -2161,35 +2173,17 @@
                       </a:endParaRPr>
                     </a:p>
                   </a:txBody>
-                  <a:tcPr marL="64008" marR="64008" marT="9144" marB="9144" anchor="ctr">
-                    <a:lnL w="6350" cap="flat" cmpd="sng" algn="ctr">
-                      <a:solidFill>
-                        <a:srgbClr val="D3DCE2"/>
-                      </a:solidFill>
-                      <a:prstDash val="solid"/>
-                      <a:round/>
-                      <a:headEnd type="none" w="med" len="med"/>
-                      <a:tailEnd type="none" w="med" len="med"/>
+                  <a:tcPr marL="73152" marR="73152" marT="36576" marB="36576" anchor="ctr">
+                    <a:lnL w="0" cap="flat" cmpd="sng" algn="ctr">
+                      <a:noFill/>
                     </a:lnL>
-                    <a:lnR w="6350" cap="flat" cmpd="sng" algn="ctr">
-                      <a:solidFill>
-                        <a:srgbClr val="D3DCE2"/>
-                      </a:solidFill>
-                      <a:prstDash val="solid"/>
-                      <a:round/>
-                      <a:headEnd type="none" w="med" len="med"/>
-                      <a:tailEnd type="none" w="med" len="med"/>
+                    <a:lnR w="0" cap="flat" cmpd="sng" algn="ctr">
+                      <a:noFill/>
                     </a:lnR>
-                    <a:lnT w="6350" cap="flat" cmpd="sng" algn="ctr">
-                      <a:solidFill>
-                        <a:srgbClr val="D3DCE2"/>
-                      </a:solidFill>
-                      <a:prstDash val="solid"/>
-                      <a:round/>
-                      <a:headEnd type="none" w="med" len="med"/>
-                      <a:tailEnd type="none" w="med" len="med"/>
+                    <a:lnT w="0" cap="flat" cmpd="sng" algn="ctr">
+                      <a:noFill/>
                     </a:lnT>
-                    <a:lnB w="6350" cap="flat" cmpd="sng" algn="ctr">
+                    <a:lnB w="9525" cap="flat" cmpd="sng" algn="ctr">
                       <a:solidFill>
                         <a:srgbClr val="D3DCE2"/>
                       </a:solidFill>
@@ -2198,13 +2192,10 @@
                       <a:headEnd type="none" w="med" len="med"/>
                       <a:tailEnd type="none" w="med" len="med"/>
                     </a:lnB>
-                    <a:solidFill>
-                      <a:srgbClr val="FFFFFF"/>
-                    </a:solidFill>
                   </a:tcPr>
                 </a:tc>
               </a:tr>
-              <a:tr h="713232">
+              <a:tr h="786384">
                 <a:tc>
                   <a:txBody>
                     <a:bodyPr/>
@@ -2222,7 +2213,7 @@
                           <a:ea typeface="Times New Roman" pitchFamily="34" charset="-122"/>
                           <a:cs typeface="Times New Roman" pitchFamily="34" charset="-120"/>
                         </a:rPr>
-                        <a:t>Grassland &amp; savanna</a:t>
+                        <a:t>Wetland</a:t>
                       </a:r>
                       <a:endParaRPr lang="en-US" sz="1400" dirty="0">
                         <a:latin typeface="Times New Roman" charset="0"/>
@@ -2231,35 +2222,17 @@
                       </a:endParaRPr>
                     </a:p>
                   </a:txBody>
-                  <a:tcPr marL="64008" marR="64008" marT="9144" marB="9144" anchor="ctr">
-                    <a:lnL w="6350" cap="flat" cmpd="sng" algn="ctr">
-                      <a:solidFill>
-                        <a:srgbClr val="D3DCE2"/>
-                      </a:solidFill>
-                      <a:prstDash val="solid"/>
-                      <a:round/>
-                      <a:headEnd type="none" w="med" len="med"/>
-                      <a:tailEnd type="none" w="med" len="med"/>
+                  <a:tcPr marL="73152" marR="73152" marT="36576" marB="36576" anchor="ctr">
+                    <a:lnL w="0" cap="flat" cmpd="sng" algn="ctr">
+                      <a:noFill/>
                     </a:lnL>
-                    <a:lnR w="6350" cap="flat" cmpd="sng" algn="ctr">
-                      <a:solidFill>
-                        <a:srgbClr val="D3DCE2"/>
-                      </a:solidFill>
-                      <a:prstDash val="solid"/>
-                      <a:round/>
-                      <a:headEnd type="none" w="med" len="med"/>
-                      <a:tailEnd type="none" w="med" len="med"/>
+                    <a:lnR w="0" cap="flat" cmpd="sng" algn="ctr">
+                      <a:noFill/>
                     </a:lnR>
-                    <a:lnT w="6350" cap="flat" cmpd="sng" algn="ctr">
-                      <a:solidFill>
-                        <a:srgbClr val="D3DCE2"/>
-                      </a:solidFill>
-                      <a:prstDash val="solid"/>
-                      <a:round/>
-                      <a:headEnd type="none" w="med" len="med"/>
-                      <a:tailEnd type="none" w="med" len="med"/>
+                    <a:lnT w="0" cap="flat" cmpd="sng" algn="ctr">
+                      <a:noFill/>
                     </a:lnT>
-                    <a:lnB w="6350" cap="flat" cmpd="sng" algn="ctr">
+                    <a:lnB w="9525" cap="flat" cmpd="sng" algn="ctr">
                       <a:solidFill>
                         <a:srgbClr val="D3DCE2"/>
                       </a:solidFill>
@@ -2268,9 +2241,6 @@
                       <a:headEnd type="none" w="med" len="med"/>
                       <a:tailEnd type="none" w="med" len="med"/>
                     </a:lnB>
-                    <a:solidFill>
-                      <a:srgbClr val="EDF2F5"/>
-                    </a:solidFill>
                   </a:tcPr>
                 </a:tc>
                 <a:tc>
@@ -2284,13 +2254,34 @@
                       <a:r>
                         <a:rPr lang="en-US" sz="1400" dirty="0">
                           <a:solidFill>
-                            <a:srgbClr val="000000"/>
-                          </a:solidFill>
-                          <a:latin typeface="Times New Roman" pitchFamily="34" charset="0"/>
-                          <a:ea typeface="Times New Roman" pitchFamily="34" charset="-122"/>
-                          <a:cs typeface="Times New Roman" pitchFamily="34" charset="-120"/>
-                        </a:rPr>
-                        <a:t>Grassland uptake fell (USA, NW China); savanna: diffuse 11 → 21%, no significant change</a:t>
+                            <a:srgbClr val="1A1F24"/>
+                          </a:solidFill>
+                          <a:latin typeface="Times New Roman" pitchFamily="34" charset="0"/>
+                          <a:ea typeface="Times New Roman" pitchFamily="34" charset="-122"/>
+                          <a:cs typeface="Times New Roman" pitchFamily="34" charset="-120"/>
+                        </a:rPr>
+                        <a:t>GPP +1.2–4.1% (California)</a:t>
+                      </a:r>
+                      <a:endParaRPr lang="en-US" sz="1400" dirty="0">
+                        <a:latin typeface="Times New Roman" charset="0"/>
+                        <a:ea typeface="Times New Roman" charset="0"/>
+                        <a:cs typeface="Times New Roman" charset="0"/>
+                      </a:endParaRPr>
+                    </a:p>
+                    <a:p>
+                      <a:pPr indent="0" marL="0">
+                        <a:buNone/>
+                      </a:pPr>
+                      <a:r>
+                        <a:rPr lang="en-US" sz="1400" dirty="0">
+                          <a:solidFill>
+                            <a:srgbClr val="1A1F24"/>
+                          </a:solidFill>
+                          <a:latin typeface="Times New Roman" pitchFamily="34" charset="0"/>
+                          <a:ea typeface="Times New Roman" pitchFamily="34" charset="-122"/>
+                          <a:cs typeface="Times New Roman" pitchFamily="34" charset="-120"/>
+                        </a:rPr>
+                        <a:t>Assimilation fell (Pantanal)</a:t>
                       </a:r>
                       <a:endParaRPr lang="en-US" sz="1400" dirty="0">
                         <a:latin typeface="Times New Roman" charset="0"/>
@@ -2299,35 +2290,17 @@
                       </a:endParaRPr>
                     </a:p>
                   </a:txBody>
-                  <a:tcPr marL="64008" marR="64008" marT="9144" marB="9144" anchor="ctr">
-                    <a:lnL w="6350" cap="flat" cmpd="sng" algn="ctr">
-                      <a:solidFill>
-                        <a:srgbClr val="D3DCE2"/>
-                      </a:solidFill>
-                      <a:prstDash val="solid"/>
-                      <a:round/>
-                      <a:headEnd type="none" w="med" len="med"/>
-                      <a:tailEnd type="none" w="med" len="med"/>
+                  <a:tcPr marL="73152" marR="73152" marT="36576" marB="36576" anchor="ctr">
+                    <a:lnL w="0" cap="flat" cmpd="sng" algn="ctr">
+                      <a:noFill/>
                     </a:lnL>
-                    <a:lnR w="6350" cap="flat" cmpd="sng" algn="ctr">
-                      <a:solidFill>
-                        <a:srgbClr val="D3DCE2"/>
-                      </a:solidFill>
-                      <a:prstDash val="solid"/>
-                      <a:round/>
-                      <a:headEnd type="none" w="med" len="med"/>
-                      <a:tailEnd type="none" w="med" len="med"/>
+                    <a:lnR w="0" cap="flat" cmpd="sng" algn="ctr">
+                      <a:noFill/>
                     </a:lnR>
-                    <a:lnT w="6350" cap="flat" cmpd="sng" algn="ctr">
-                      <a:solidFill>
-                        <a:srgbClr val="D3DCE2"/>
-                      </a:solidFill>
-                      <a:prstDash val="solid"/>
-                      <a:round/>
-                      <a:headEnd type="none" w="med" len="med"/>
-                      <a:tailEnd type="none" w="med" len="med"/>
+                    <a:lnT w="0" cap="flat" cmpd="sng" algn="ctr">
+                      <a:noFill/>
                     </a:lnT>
-                    <a:lnB w="6350" cap="flat" cmpd="sng" algn="ctr">
+                    <a:lnB w="9525" cap="flat" cmpd="sng" algn="ctr">
                       <a:solidFill>
                         <a:srgbClr val="D3DCE2"/>
                       </a:solidFill>
@@ -2336,9 +2309,6 @@
                       <a:headEnd type="none" w="med" len="med"/>
                       <a:tailEnd type="none" w="med" len="med"/>
                     </a:lnB>
-                    <a:solidFill>
-                      <a:srgbClr val="EDF2F5"/>
-                    </a:solidFill>
                   </a:tcPr>
                 </a:tc>
                 <a:tc>
@@ -2352,7 +2322,29 @@
                       <a:r>
                         <a:rPr lang="en-US" sz="1400" b="1" dirty="0">
                           <a:solidFill>
-                            <a:srgbClr val="000000"/>
+                            <a:schemeClr val="accent3"/>
+                          </a:solidFill>
+                          <a:latin typeface="Times New Roman" pitchFamily="34" charset="0"/>
+                          <a:ea typeface="Times New Roman" pitchFamily="34" charset="-122"/>
+                          <a:cs typeface="Times New Roman" pitchFamily="34" charset="-120"/>
+                        </a:rPr>
+                        <a:t>Positive</a:t>
+                      </a:r>
+                      <a:r>
+                        <a:rPr lang="en-US" sz="1400" dirty="0">
+                          <a:solidFill>
+                            <a:srgbClr val="1A1F24"/>
+                          </a:solidFill>
+                          <a:latin typeface="Times New Roman" pitchFamily="34" charset="0"/>
+                          <a:ea typeface="Times New Roman" pitchFamily="34" charset="-122"/>
+                          <a:cs typeface="Times New Roman" pitchFamily="34" charset="-120"/>
+                        </a:rPr>
+                        <a:t> with scattering smoke; </a:t>
+                      </a:r>
+                      <a:r>
+                        <a:rPr lang="en-US" sz="1400" b="1" dirty="0">
+                          <a:solidFill>
+                            <a:schemeClr val="accent5"/>
                           </a:solidFill>
                           <a:latin typeface="Times New Roman" pitchFamily="34" charset="0"/>
                           <a:ea typeface="Times New Roman" pitchFamily="34" charset="-122"/>
@@ -2363,13 +2355,13 @@
                       <a:r>
                         <a:rPr lang="en-US" sz="1400" dirty="0">
                           <a:solidFill>
-                            <a:srgbClr val="000000"/>
-                          </a:solidFill>
-                          <a:latin typeface="Times New Roman" pitchFamily="34" charset="0"/>
-                          <a:ea typeface="Times New Roman" pitchFamily="34" charset="-122"/>
-                          <a:cs typeface="Times New Roman" pitchFamily="34" charset="-120"/>
-                        </a:rPr>
-                        <a:t> at AOD &gt; 0.6 in short, open canopy; no change in open savanna</a:t>
+                            <a:srgbClr val="1A1F24"/>
+                          </a:solidFill>
+                          <a:latin typeface="Times New Roman" pitchFamily="34" charset="0"/>
+                          <a:ea typeface="Times New Roman" pitchFamily="34" charset="-122"/>
+                          <a:cs typeface="Times New Roman" pitchFamily="34" charset="-120"/>
+                        </a:rPr>
+                        <a:t> with black carbon</a:t>
                       </a:r>
                       <a:endParaRPr lang="en-US" sz="1400" dirty="0">
                         <a:latin typeface="Times New Roman" charset="0"/>
@@ -2378,35 +2370,17 @@
                       </a:endParaRPr>
                     </a:p>
                   </a:txBody>
-                  <a:tcPr marL="64008" marR="64008" marT="9144" marB="9144" anchor="ctr">
-                    <a:lnL w="6350" cap="flat" cmpd="sng" algn="ctr">
-                      <a:solidFill>
-                        <a:srgbClr val="D3DCE2"/>
-                      </a:solidFill>
-                      <a:prstDash val="solid"/>
-                      <a:round/>
-                      <a:headEnd type="none" w="med" len="med"/>
-                      <a:tailEnd type="none" w="med" len="med"/>
+                  <a:tcPr marL="73152" marR="73152" marT="36576" marB="36576" anchor="ctr">
+                    <a:lnL w="0" cap="flat" cmpd="sng" algn="ctr">
+                      <a:noFill/>
                     </a:lnL>
-                    <a:lnR w="6350" cap="flat" cmpd="sng" algn="ctr">
-                      <a:solidFill>
-                        <a:srgbClr val="D3DCE2"/>
-                      </a:solidFill>
-                      <a:prstDash val="solid"/>
-                      <a:round/>
-                      <a:headEnd type="none" w="med" len="med"/>
-                      <a:tailEnd type="none" w="med" len="med"/>
+                    <a:lnR w="0" cap="flat" cmpd="sng" algn="ctr">
+                      <a:noFill/>
                     </a:lnR>
-                    <a:lnT w="6350" cap="flat" cmpd="sng" algn="ctr">
-                      <a:solidFill>
-                        <a:srgbClr val="D3DCE2"/>
-                      </a:solidFill>
-                      <a:prstDash val="solid"/>
-                      <a:round/>
-                      <a:headEnd type="none" w="med" len="med"/>
-                      <a:tailEnd type="none" w="med" len="med"/>
+                    <a:lnT w="0" cap="flat" cmpd="sng" algn="ctr">
+                      <a:noFill/>
                     </a:lnT>
-                    <a:lnB w="6350" cap="flat" cmpd="sng" algn="ctr">
+                    <a:lnB w="9525" cap="flat" cmpd="sng" algn="ctr">
                       <a:solidFill>
                         <a:srgbClr val="D3DCE2"/>
                       </a:solidFill>
@@ -2415,9 +2389,6 @@
                       <a:headEnd type="none" w="med" len="med"/>
                       <a:tailEnd type="none" w="med" len="med"/>
                     </a:lnB>
-                    <a:solidFill>
-                      <a:srgbClr val="EDF2F5"/>
-                    </a:solidFill>
                   </a:tcPr>
                 </a:tc>
                 <a:tc>
@@ -2437,7 +2408,7 @@
                           <a:ea typeface="Times New Roman" pitchFamily="34" charset="-122"/>
                           <a:cs typeface="Times New Roman" pitchFamily="34" charset="-120"/>
                         </a:rPr>
-                        <a:t>Strada et al., 2015</a:t>
+                        <a:t>Hemes et al., 2020</a:t>
                       </a:r>
                       <a:endParaRPr lang="en-US" sz="1400" dirty="0">
                         <a:latin typeface="Times New Roman" charset="0"/>
@@ -2458,28 +2429,7 @@
                           <a:ea typeface="Times New Roman" pitchFamily="34" charset="-122"/>
                           <a:cs typeface="Times New Roman" pitchFamily="34" charset="-120"/>
                         </a:rPr>
-                        <a:t>Jing et al., 2010</a:t>
-                      </a:r>
-                      <a:endParaRPr lang="en-US" sz="1400" dirty="0">
-                        <a:latin typeface="Times New Roman" charset="0"/>
-                        <a:ea typeface="Times New Roman" charset="0"/>
-                        <a:cs typeface="Times New Roman" charset="0"/>
-                      </a:endParaRPr>
-                    </a:p>
-                    <a:p>
-                      <a:pPr indent="0" marL="0">
-                        <a:buNone/>
-                      </a:pPr>
-                      <a:r>
-                        <a:rPr lang="en-US" sz="1400" i="1" dirty="0">
-                          <a:solidFill>
-                            <a:schemeClr val="accent1"/>
-                          </a:solidFill>
-                          <a:latin typeface="Times New Roman" pitchFamily="34" charset="0"/>
-                          <a:ea typeface="Times New Roman" pitchFamily="34" charset="-122"/>
-                          <a:cs typeface="Times New Roman" pitchFamily="34" charset="-120"/>
-                        </a:rPr>
-                        <a:t>Kanniah et al., 2010</a:t>
+                        <a:t>Curado et al., 2024</a:t>
                       </a:r>
                       <a:endParaRPr lang="en-US" sz="1400" dirty="0">
                         <a:latin typeface="Times New Roman" charset="0"/>
@@ -2488,35 +2438,17 @@
                       </a:endParaRPr>
                     </a:p>
                   </a:txBody>
-                  <a:tcPr marL="64008" marR="64008" marT="9144" marB="9144" anchor="ctr">
-                    <a:lnL w="6350" cap="flat" cmpd="sng" algn="ctr">
-                      <a:solidFill>
-                        <a:srgbClr val="D3DCE2"/>
-                      </a:solidFill>
-                      <a:prstDash val="solid"/>
-                      <a:round/>
-                      <a:headEnd type="none" w="med" len="med"/>
-                      <a:tailEnd type="none" w="med" len="med"/>
+                  <a:tcPr marL="73152" marR="73152" marT="36576" marB="36576" anchor="ctr">
+                    <a:lnL w="0" cap="flat" cmpd="sng" algn="ctr">
+                      <a:noFill/>
                     </a:lnL>
-                    <a:lnR w="6350" cap="flat" cmpd="sng" algn="ctr">
-                      <a:solidFill>
-                        <a:srgbClr val="D3DCE2"/>
-                      </a:solidFill>
-                      <a:prstDash val="solid"/>
-                      <a:round/>
-                      <a:headEnd type="none" w="med" len="med"/>
-                      <a:tailEnd type="none" w="med" len="med"/>
+                    <a:lnR w="0" cap="flat" cmpd="sng" algn="ctr">
+                      <a:noFill/>
                     </a:lnR>
-                    <a:lnT w="6350" cap="flat" cmpd="sng" algn="ctr">
-                      <a:solidFill>
-                        <a:srgbClr val="D3DCE2"/>
-                      </a:solidFill>
-                      <a:prstDash val="solid"/>
-                      <a:round/>
-                      <a:headEnd type="none" w="med" len="med"/>
-                      <a:tailEnd type="none" w="med" len="med"/>
+                    <a:lnT w="0" cap="flat" cmpd="sng" algn="ctr">
+                      <a:noFill/>
                     </a:lnT>
-                    <a:lnB w="6350" cap="flat" cmpd="sng" algn="ctr">
+                    <a:lnB w="9525" cap="flat" cmpd="sng" algn="ctr">
                       <a:solidFill>
                         <a:srgbClr val="D3DCE2"/>
                       </a:solidFill>
@@ -2525,13 +2457,10 @@
                       <a:headEnd type="none" w="med" len="med"/>
                       <a:tailEnd type="none" w="med" len="med"/>
                     </a:lnB>
-                    <a:solidFill>
-                      <a:srgbClr val="EDF2F5"/>
-                    </a:solidFill>
                   </a:tcPr>
                 </a:tc>
               </a:tr>
-              <a:tr h="713232">
+              <a:tr h="841248">
                 <a:tc>
                   <a:txBody>
                     <a:bodyPr/>
@@ -2549,7 +2478,7 @@
                           <a:ea typeface="Times New Roman" pitchFamily="34" charset="-122"/>
                           <a:cs typeface="Times New Roman" pitchFamily="34" charset="-120"/>
                         </a:rPr>
-                        <a:t>Wetland</a:t>
+                        <a:t>All biomes (global)</a:t>
                       </a:r>
                       <a:endParaRPr lang="en-US" sz="1400" dirty="0">
                         <a:latin typeface="Times New Roman" charset="0"/>
@@ -2558,46 +2487,19 @@
                       </a:endParaRPr>
                     </a:p>
                   </a:txBody>
-                  <a:tcPr marL="64008" marR="64008" marT="9144" marB="9144" anchor="ctr">
-                    <a:lnL w="6350" cap="flat" cmpd="sng" algn="ctr">
-                      <a:solidFill>
-                        <a:srgbClr val="D3DCE2"/>
-                      </a:solidFill>
-                      <a:prstDash val="solid"/>
-                      <a:round/>
-                      <a:headEnd type="none" w="med" len="med"/>
-                      <a:tailEnd type="none" w="med" len="med"/>
+                  <a:tcPr marL="73152" marR="73152" marT="36576" marB="36576" anchor="ctr">
+                    <a:lnL w="0" cap="flat" cmpd="sng" algn="ctr">
+                      <a:noFill/>
                     </a:lnL>
-                    <a:lnR w="6350" cap="flat" cmpd="sng" algn="ctr">
-                      <a:solidFill>
-                        <a:srgbClr val="D3DCE2"/>
-                      </a:solidFill>
-                      <a:prstDash val="solid"/>
-                      <a:round/>
-                      <a:headEnd type="none" w="med" len="med"/>
-                      <a:tailEnd type="none" w="med" len="med"/>
+                    <a:lnR w="0" cap="flat" cmpd="sng" algn="ctr">
+                      <a:noFill/>
                     </a:lnR>
-                    <a:lnT w="6350" cap="flat" cmpd="sng" algn="ctr">
-                      <a:solidFill>
-                        <a:srgbClr val="D3DCE2"/>
-                      </a:solidFill>
-                      <a:prstDash val="solid"/>
-                      <a:round/>
-                      <a:headEnd type="none" w="med" len="med"/>
-                      <a:tailEnd type="none" w="med" len="med"/>
+                    <a:lnT w="0" cap="flat" cmpd="sng" algn="ctr">
+                      <a:noFill/>
                     </a:lnT>
-                    <a:lnB w="6350" cap="flat" cmpd="sng" algn="ctr">
-                      <a:solidFill>
-                        <a:srgbClr val="D3DCE2"/>
-                      </a:solidFill>
-                      <a:prstDash val="solid"/>
-                      <a:round/>
-                      <a:headEnd type="none" w="med" len="med"/>
-                      <a:tailEnd type="none" w="med" len="med"/>
+                    <a:lnB w="0" cap="flat" cmpd="sng" algn="ctr">
+                      <a:noFill/>
                     </a:lnB>
-                    <a:solidFill>
-                      <a:srgbClr val="FFFFFF"/>
-                    </a:solidFill>
                   </a:tcPr>
                 </a:tc>
                 <a:tc>
@@ -2611,13 +2513,45 @@
                       <a:r>
                         <a:rPr lang="en-US" sz="1400" dirty="0">
                           <a:solidFill>
-                            <a:srgbClr val="000000"/>
-                          </a:solidFill>
-                          <a:latin typeface="Times New Roman" pitchFamily="34" charset="0"/>
-                          <a:ea typeface="Times New Roman" pitchFamily="34" charset="-122"/>
-                          <a:cs typeface="Times New Roman" pitchFamily="34" charset="-120"/>
-                        </a:rPr>
-                        <a:t>GPP +1.2–4.1% (California); assimilation lowered (Pantanal)</a:t>
+                            <a:srgbClr val="1A1F24"/>
+                          </a:solidFill>
+                          <a:latin typeface="Times New Roman" pitchFamily="34" charset="0"/>
+                          <a:ea typeface="Times New Roman" pitchFamily="34" charset="-122"/>
+                          <a:cs typeface="Times New Roman" pitchFamily="34" charset="-120"/>
+                        </a:rPr>
+                        <a:t>GPP +0.95, NPP +1.23 Pg C yr</a:t>
+                      </a:r>
+                      <a:r>
+                        <a:rPr lang="en-US" sz="1400" baseline="30000" dirty="0">
+                          <a:solidFill>
+                            <a:srgbClr val="1A1F24"/>
+                          </a:solidFill>
+                          <a:latin typeface="Times New Roman" pitchFamily="34" charset="0"/>
+                          <a:ea typeface="Times New Roman" pitchFamily="34" charset="-122"/>
+                          <a:cs typeface="Times New Roman" pitchFamily="34" charset="-120"/>
+                        </a:rPr>
+                        <a:t>−1</a:t>
+                      </a:r>
+                      <a:endParaRPr lang="en-US" sz="1400" dirty="0">
+                        <a:latin typeface="Times New Roman" charset="0"/>
+                        <a:ea typeface="Times New Roman" charset="0"/>
+                        <a:cs typeface="Times New Roman" charset="0"/>
+                      </a:endParaRPr>
+                    </a:p>
+                    <a:p>
+                      <a:pPr indent="0" marL="0">
+                        <a:buNone/>
+                      </a:pPr>
+                      <a:r>
+                        <a:rPr lang="en-US" sz="1400" dirty="0">
+                          <a:solidFill>
+                            <a:srgbClr val="1A1F24"/>
+                          </a:solidFill>
+                          <a:latin typeface="Times New Roman" pitchFamily="34" charset="0"/>
+                          <a:ea typeface="Times New Roman" pitchFamily="34" charset="-122"/>
+                          <a:cs typeface="Times New Roman" pitchFamily="34" charset="-120"/>
+                        </a:rPr>
+                        <a:t>Land sink ~¼ higher, 1960–1999</a:t>
                       </a:r>
                       <a:endParaRPr lang="en-US" sz="1400" dirty="0">
                         <a:latin typeface="Times New Roman" charset="0"/>
@@ -2626,46 +2560,19 @@
                       </a:endParaRPr>
                     </a:p>
                   </a:txBody>
-                  <a:tcPr marL="64008" marR="64008" marT="9144" marB="9144" anchor="ctr">
-                    <a:lnL w="6350" cap="flat" cmpd="sng" algn="ctr">
-                      <a:solidFill>
-                        <a:srgbClr val="D3DCE2"/>
-                      </a:solidFill>
-                      <a:prstDash val="solid"/>
-                      <a:round/>
-                      <a:headEnd type="none" w="med" len="med"/>
-                      <a:tailEnd type="none" w="med" len="med"/>
+                  <a:tcPr marL="73152" marR="73152" marT="36576" marB="36576" anchor="ctr">
+                    <a:lnL w="0" cap="flat" cmpd="sng" algn="ctr">
+                      <a:noFill/>
                     </a:lnL>
-                    <a:lnR w="6350" cap="flat" cmpd="sng" algn="ctr">
-                      <a:solidFill>
-                        <a:srgbClr val="D3DCE2"/>
-                      </a:solidFill>
-                      <a:prstDash val="solid"/>
-                      <a:round/>
-                      <a:headEnd type="none" w="med" len="med"/>
-                      <a:tailEnd type="none" w="med" len="med"/>
+                    <a:lnR w="0" cap="flat" cmpd="sng" algn="ctr">
+                      <a:noFill/>
                     </a:lnR>
-                    <a:lnT w="6350" cap="flat" cmpd="sng" algn="ctr">
-                      <a:solidFill>
-                        <a:srgbClr val="D3DCE2"/>
-                      </a:solidFill>
-                      <a:prstDash val="solid"/>
-                      <a:round/>
-                      <a:headEnd type="none" w="med" len="med"/>
-                      <a:tailEnd type="none" w="med" len="med"/>
+                    <a:lnT w="0" cap="flat" cmpd="sng" algn="ctr">
+                      <a:noFill/>
                     </a:lnT>
-                    <a:lnB w="6350" cap="flat" cmpd="sng" algn="ctr">
-                      <a:solidFill>
-                        <a:srgbClr val="D3DCE2"/>
-                      </a:solidFill>
-                      <a:prstDash val="solid"/>
-                      <a:round/>
-                      <a:headEnd type="none" w="med" len="med"/>
-                      <a:tailEnd type="none" w="med" len="med"/>
+                    <a:lnB w="0" cap="flat" cmpd="sng" algn="ctr">
+                      <a:noFill/>
                     </a:lnB>
-                    <a:solidFill>
-                      <a:srgbClr val="FFFFFF"/>
-                    </a:solidFill>
                   </a:tcPr>
                 </a:tc>
                 <a:tc>
@@ -2679,7 +2586,7 @@
                       <a:r>
                         <a:rPr lang="en-US" sz="1400" b="1" dirty="0">
                           <a:solidFill>
-                            <a:srgbClr val="000000"/>
+                            <a:schemeClr val="accent3"/>
                           </a:solidFill>
                           <a:latin typeface="Times New Roman" pitchFamily="34" charset="0"/>
                           <a:ea typeface="Times New Roman" pitchFamily="34" charset="-122"/>
@@ -2690,35 +2597,13 @@
                       <a:r>
                         <a:rPr lang="en-US" sz="1400" dirty="0">
                           <a:solidFill>
-                            <a:srgbClr val="000000"/>
-                          </a:solidFill>
-                          <a:latin typeface="Times New Roman" pitchFamily="34" charset="0"/>
-                          <a:ea typeface="Times New Roman" pitchFamily="34" charset="-122"/>
-                          <a:cs typeface="Times New Roman" pitchFamily="34" charset="-120"/>
-                        </a:rPr>
-                        <a:t> under scattering wildfire smoke; </a:t>
-                      </a:r>
-                      <a:r>
-                        <a:rPr lang="en-US" sz="1400" b="1" dirty="0">
-                          <a:solidFill>
-                            <a:srgbClr val="000000"/>
-                          </a:solidFill>
-                          <a:latin typeface="Times New Roman" pitchFamily="34" charset="0"/>
-                          <a:ea typeface="Times New Roman" pitchFamily="34" charset="-122"/>
-                          <a:cs typeface="Times New Roman" pitchFamily="34" charset="-120"/>
-                        </a:rPr>
-                        <a:t>negative</a:t>
-                      </a:r>
-                      <a:r>
-                        <a:rPr lang="en-US" sz="1400" dirty="0">
-                          <a:solidFill>
-                            <a:srgbClr val="000000"/>
-                          </a:solidFill>
-                          <a:latin typeface="Times New Roman" pitchFamily="34" charset="0"/>
-                          <a:ea typeface="Times New Roman" pitchFamily="34" charset="-122"/>
-                          <a:cs typeface="Times New Roman" pitchFamily="34" charset="-120"/>
-                        </a:rPr>
-                        <a:t> under black carbon</a:t>
+                            <a:srgbClr val="1A1F24"/>
+                          </a:solidFill>
+                          <a:latin typeface="Times New Roman" pitchFamily="34" charset="0"/>
+                          <a:ea typeface="Times New Roman" pitchFamily="34" charset="-122"/>
+                          <a:cs typeface="Times New Roman" pitchFamily="34" charset="-120"/>
+                        </a:rPr>
+                        <a:t>; smaller under clouds (all‑sky 0.95 vs clear‑sky 8.91)</a:t>
                       </a:r>
                       <a:endParaRPr lang="en-US" sz="1400" dirty="0">
                         <a:latin typeface="Times New Roman" charset="0"/>
@@ -2727,46 +2612,19 @@
                       </a:endParaRPr>
                     </a:p>
                   </a:txBody>
-                  <a:tcPr marL="64008" marR="64008" marT="9144" marB="9144" anchor="ctr">
-                    <a:lnL w="6350" cap="flat" cmpd="sng" algn="ctr">
-                      <a:solidFill>
-                        <a:srgbClr val="D3DCE2"/>
-                      </a:solidFill>
-                      <a:prstDash val="solid"/>
-                      <a:round/>
-                      <a:headEnd type="none" w="med" len="med"/>
-                      <a:tailEnd type="none" w="med" len="med"/>
+                  <a:tcPr marL="73152" marR="73152" marT="36576" marB="36576" anchor="ctr">
+                    <a:lnL w="0" cap="flat" cmpd="sng" algn="ctr">
+                      <a:noFill/>
                     </a:lnL>
-                    <a:lnR w="6350" cap="flat" cmpd="sng" algn="ctr">
-                      <a:solidFill>
-                        <a:srgbClr val="D3DCE2"/>
-                      </a:solidFill>
-                      <a:prstDash val="solid"/>
-                      <a:round/>
-                      <a:headEnd type="none" w="med" len="med"/>
-                      <a:tailEnd type="none" w="med" len="med"/>
+                    <a:lnR w="0" cap="flat" cmpd="sng" algn="ctr">
+                      <a:noFill/>
                     </a:lnR>
-                    <a:lnT w="6350" cap="flat" cmpd="sng" algn="ctr">
-                      <a:solidFill>
-                        <a:srgbClr val="D3DCE2"/>
-                      </a:solidFill>
-                      <a:prstDash val="solid"/>
-                      <a:round/>
-                      <a:headEnd type="none" w="med" len="med"/>
-                      <a:tailEnd type="none" w="med" len="med"/>
+                    <a:lnT w="0" cap="flat" cmpd="sng" algn="ctr">
+                      <a:noFill/>
                     </a:lnT>
-                    <a:lnB w="6350" cap="flat" cmpd="sng" algn="ctr">
-                      <a:solidFill>
-                        <a:srgbClr val="D3DCE2"/>
-                      </a:solidFill>
-                      <a:prstDash val="solid"/>
-                      <a:round/>
-                      <a:headEnd type="none" w="med" len="med"/>
-                      <a:tailEnd type="none" w="med" len="med"/>
+                    <a:lnB w="0" cap="flat" cmpd="sng" algn="ctr">
+                      <a:noFill/>
                     </a:lnB>
-                    <a:solidFill>
-                      <a:srgbClr val="FFFFFF"/>
-                    </a:solidFill>
                   </a:tcPr>
                 </a:tc>
                 <a:tc>
@@ -2786,7 +2644,7 @@
                           <a:ea typeface="Times New Roman" pitchFamily="34" charset="-122"/>
                           <a:cs typeface="Times New Roman" pitchFamily="34" charset="-120"/>
                         </a:rPr>
-                        <a:t>Hemes et al., 2020</a:t>
+                        <a:t>Zhou et al., 2022</a:t>
                       </a:r>
                       <a:endParaRPr lang="en-US" sz="1400" dirty="0">
                         <a:latin typeface="Times New Roman" charset="0"/>
@@ -2807,7 +2665,28 @@
                           <a:ea typeface="Times New Roman" pitchFamily="34" charset="-122"/>
                           <a:cs typeface="Times New Roman" pitchFamily="34" charset="-120"/>
                         </a:rPr>
-                        <a:t>Curado et al., 2024</a:t>
+                        <a:t>Rap et al., 2018</a:t>
+                      </a:r>
+                      <a:endParaRPr lang="en-US" sz="1400" dirty="0">
+                        <a:latin typeface="Times New Roman" charset="0"/>
+                        <a:ea typeface="Times New Roman" charset="0"/>
+                        <a:cs typeface="Times New Roman" charset="0"/>
+                      </a:endParaRPr>
+                    </a:p>
+                    <a:p>
+                      <a:pPr indent="0" marL="0">
+                        <a:buNone/>
+                      </a:pPr>
+                      <a:r>
+                        <a:rPr lang="en-US" sz="1400" i="1" dirty="0">
+                          <a:solidFill>
+                            <a:schemeClr val="accent1"/>
+                          </a:solidFill>
+                          <a:latin typeface="Times New Roman" pitchFamily="34" charset="0"/>
+                          <a:ea typeface="Times New Roman" pitchFamily="34" charset="-122"/>
+                          <a:cs typeface="Times New Roman" pitchFamily="34" charset="-120"/>
+                        </a:rPr>
+                        <a:t>Mercado et al., 2009</a:t>
                       </a:r>
                       <a:endParaRPr lang="en-US" sz="1400" dirty="0">
                         <a:latin typeface="Times New Roman" charset="0"/>
@@ -2816,395 +2695,19 @@
                       </a:endParaRPr>
                     </a:p>
                   </a:txBody>
-                  <a:tcPr marL="64008" marR="64008" marT="9144" marB="9144" anchor="ctr">
-                    <a:lnL w="6350" cap="flat" cmpd="sng" algn="ctr">
-                      <a:solidFill>
-                        <a:srgbClr val="D3DCE2"/>
-                      </a:solidFill>
-                      <a:prstDash val="solid"/>
-                      <a:round/>
-                      <a:headEnd type="none" w="med" len="med"/>
-                      <a:tailEnd type="none" w="med" len="med"/>
+                  <a:tcPr marL="73152" marR="73152" marT="36576" marB="36576" anchor="ctr">
+                    <a:lnL w="0" cap="flat" cmpd="sng" algn="ctr">
+                      <a:noFill/>
                     </a:lnL>
-                    <a:lnR w="6350" cap="flat" cmpd="sng" algn="ctr">
-                      <a:solidFill>
-                        <a:srgbClr val="D3DCE2"/>
-                      </a:solidFill>
-                      <a:prstDash val="solid"/>
-                      <a:round/>
-                      <a:headEnd type="none" w="med" len="med"/>
-                      <a:tailEnd type="none" w="med" len="med"/>
+                    <a:lnR w="0" cap="flat" cmpd="sng" algn="ctr">
+                      <a:noFill/>
                     </a:lnR>
-                    <a:lnT w="6350" cap="flat" cmpd="sng" algn="ctr">
-                      <a:solidFill>
-                        <a:srgbClr val="D3DCE2"/>
-                      </a:solidFill>
-                      <a:prstDash val="solid"/>
-                      <a:round/>
-                      <a:headEnd type="none" w="med" len="med"/>
-                      <a:tailEnd type="none" w="med" len="med"/>
+                    <a:lnT w="0" cap="flat" cmpd="sng" algn="ctr">
+                      <a:noFill/>
                     </a:lnT>
-                    <a:lnB w="6350" cap="flat" cmpd="sng" algn="ctr">
-                      <a:solidFill>
-                        <a:srgbClr val="D3DCE2"/>
-                      </a:solidFill>
-                      <a:prstDash val="solid"/>
-                      <a:round/>
-                      <a:headEnd type="none" w="med" len="med"/>
-                      <a:tailEnd type="none" w="med" len="med"/>
+                    <a:lnB w="0" cap="flat" cmpd="sng" algn="ctr">
+                      <a:noFill/>
                     </a:lnB>
-                    <a:solidFill>
-                      <a:srgbClr val="FFFFFF"/>
-                    </a:solidFill>
-                  </a:tcPr>
-                </a:tc>
-              </a:tr>
-              <a:tr h="713232">
-                <a:tc>
-                  <a:txBody>
-                    <a:bodyPr/>
-                    <a:lstStyle/>
-                    <a:p>
-                      <a:pPr indent="0" marL="0">
-                        <a:buNone/>
-                      </a:pPr>
-                      <a:r>
-                        <a:rPr lang="en-US" sz="1400" b="1" dirty="0">
-                          <a:solidFill>
-                            <a:schemeClr val="tx2"/>
-                          </a:solidFill>
-                          <a:latin typeface="Times New Roman" pitchFamily="34" charset="0"/>
-                          <a:ea typeface="Times New Roman" pitchFamily="34" charset="-122"/>
-                          <a:cs typeface="Times New Roman" pitchFamily="34" charset="-120"/>
-                        </a:rPr>
-                        <a:t>All biomes (global)</a:t>
-                      </a:r>
-                      <a:endParaRPr lang="en-US" sz="1400" dirty="0">
-                        <a:latin typeface="Times New Roman" charset="0"/>
-                        <a:ea typeface="Times New Roman" charset="0"/>
-                        <a:cs typeface="Times New Roman" charset="0"/>
-                      </a:endParaRPr>
-                    </a:p>
-                  </a:txBody>
-                  <a:tcPr marL="64008" marR="64008" marT="9144" marB="9144" anchor="ctr">
-                    <a:lnL w="6350" cap="flat" cmpd="sng" algn="ctr">
-                      <a:solidFill>
-                        <a:srgbClr val="D3DCE2"/>
-                      </a:solidFill>
-                      <a:prstDash val="solid"/>
-                      <a:round/>
-                      <a:headEnd type="none" w="med" len="med"/>
-                      <a:tailEnd type="none" w="med" len="med"/>
-                    </a:lnL>
-                    <a:lnR w="6350" cap="flat" cmpd="sng" algn="ctr">
-                      <a:solidFill>
-                        <a:srgbClr val="D3DCE2"/>
-                      </a:solidFill>
-                      <a:prstDash val="solid"/>
-                      <a:round/>
-                      <a:headEnd type="none" w="med" len="med"/>
-                      <a:tailEnd type="none" w="med" len="med"/>
-                    </a:lnR>
-                    <a:lnT w="6350" cap="flat" cmpd="sng" algn="ctr">
-                      <a:solidFill>
-                        <a:srgbClr val="D3DCE2"/>
-                      </a:solidFill>
-                      <a:prstDash val="solid"/>
-                      <a:round/>
-                      <a:headEnd type="none" w="med" len="med"/>
-                      <a:tailEnd type="none" w="med" len="med"/>
-                    </a:lnT>
-                    <a:lnB w="6350" cap="flat" cmpd="sng" algn="ctr">
-                      <a:solidFill>
-                        <a:srgbClr val="D3DCE2"/>
-                      </a:solidFill>
-                      <a:prstDash val="solid"/>
-                      <a:round/>
-                      <a:headEnd type="none" w="med" len="med"/>
-                      <a:tailEnd type="none" w="med" len="med"/>
-                    </a:lnB>
-                    <a:solidFill>
-                      <a:srgbClr val="EDF2F5"/>
-                    </a:solidFill>
-                  </a:tcPr>
-                </a:tc>
-                <a:tc>
-                  <a:txBody>
-                    <a:bodyPr/>
-                    <a:lstStyle/>
-                    <a:p>
-                      <a:pPr indent="0" marL="0">
-                        <a:buNone/>
-                      </a:pPr>
-                      <a:r>
-                        <a:rPr lang="en-US" sz="1400" dirty="0">
-                          <a:solidFill>
-                            <a:srgbClr val="000000"/>
-                          </a:solidFill>
-                          <a:latin typeface="Times New Roman" pitchFamily="34" charset="0"/>
-                          <a:ea typeface="Times New Roman" pitchFamily="34" charset="-122"/>
-                          <a:cs typeface="Times New Roman" pitchFamily="34" charset="-120"/>
-                        </a:rPr>
-                        <a:t>NPP +1.23, GPP +0.95 Pg C yr</a:t>
-                      </a:r>
-                      <a:r>
-                        <a:rPr lang="en-US" sz="1400" baseline="30000" dirty="0">
-                          <a:solidFill>
-                            <a:srgbClr val="000000"/>
-                          </a:solidFill>
-                          <a:latin typeface="Times New Roman" pitchFamily="34" charset="0"/>
-                          <a:ea typeface="Times New Roman" pitchFamily="34" charset="-122"/>
-                          <a:cs typeface="Times New Roman" pitchFamily="34" charset="-120"/>
-                        </a:rPr>
-                        <a:t>−1</a:t>
-                      </a:r>
-                      <a:r>
-                        <a:rPr lang="en-US" sz="1400" dirty="0">
-                          <a:solidFill>
-                            <a:srgbClr val="000000"/>
-                          </a:solidFill>
-                          <a:latin typeface="Times New Roman" pitchFamily="34" charset="0"/>
-                          <a:ea typeface="Times New Roman" pitchFamily="34" charset="-122"/>
-                          <a:cs typeface="Times New Roman" pitchFamily="34" charset="-120"/>
-                        </a:rPr>
-                        <a:t>; land sink ~¼ higher in 1960‑1999</a:t>
-                      </a:r>
-                      <a:endParaRPr lang="en-US" sz="1400" dirty="0">
-                        <a:latin typeface="Times New Roman" charset="0"/>
-                        <a:ea typeface="Times New Roman" charset="0"/>
-                        <a:cs typeface="Times New Roman" charset="0"/>
-                      </a:endParaRPr>
-                    </a:p>
-                  </a:txBody>
-                  <a:tcPr marL="64008" marR="64008" marT="9144" marB="9144" anchor="ctr">
-                    <a:lnL w="6350" cap="flat" cmpd="sng" algn="ctr">
-                      <a:solidFill>
-                        <a:srgbClr val="D3DCE2"/>
-                      </a:solidFill>
-                      <a:prstDash val="solid"/>
-                      <a:round/>
-                      <a:headEnd type="none" w="med" len="med"/>
-                      <a:tailEnd type="none" w="med" len="med"/>
-                    </a:lnL>
-                    <a:lnR w="6350" cap="flat" cmpd="sng" algn="ctr">
-                      <a:solidFill>
-                        <a:srgbClr val="D3DCE2"/>
-                      </a:solidFill>
-                      <a:prstDash val="solid"/>
-                      <a:round/>
-                      <a:headEnd type="none" w="med" len="med"/>
-                      <a:tailEnd type="none" w="med" len="med"/>
-                    </a:lnR>
-                    <a:lnT w="6350" cap="flat" cmpd="sng" algn="ctr">
-                      <a:solidFill>
-                        <a:srgbClr val="D3DCE2"/>
-                      </a:solidFill>
-                      <a:prstDash val="solid"/>
-                      <a:round/>
-                      <a:headEnd type="none" w="med" len="med"/>
-                      <a:tailEnd type="none" w="med" len="med"/>
-                    </a:lnT>
-                    <a:lnB w="6350" cap="flat" cmpd="sng" algn="ctr">
-                      <a:solidFill>
-                        <a:srgbClr val="D3DCE2"/>
-                      </a:solidFill>
-                      <a:prstDash val="solid"/>
-                      <a:round/>
-                      <a:headEnd type="none" w="med" len="med"/>
-                      <a:tailEnd type="none" w="med" len="med"/>
-                    </a:lnB>
-                    <a:solidFill>
-                      <a:srgbClr val="EDF2F5"/>
-                    </a:solidFill>
-                  </a:tcPr>
-                </a:tc>
-                <a:tc>
-                  <a:txBody>
-                    <a:bodyPr/>
-                    <a:lstStyle/>
-                    <a:p>
-                      <a:pPr indent="0" marL="0">
-                        <a:buNone/>
-                      </a:pPr>
-                      <a:r>
-                        <a:rPr lang="en-US" sz="1400" b="1" dirty="0">
-                          <a:solidFill>
-                            <a:srgbClr val="000000"/>
-                          </a:solidFill>
-                          <a:latin typeface="Times New Roman" pitchFamily="34" charset="0"/>
-                          <a:ea typeface="Times New Roman" pitchFamily="34" charset="-122"/>
-                          <a:cs typeface="Times New Roman" pitchFamily="34" charset="-120"/>
-                        </a:rPr>
-                        <a:t>Positive</a:t>
-                      </a:r>
-                      <a:r>
-                        <a:rPr lang="en-US" sz="1400" dirty="0">
-                          <a:solidFill>
-                            <a:srgbClr val="000000"/>
-                          </a:solidFill>
-                          <a:latin typeface="Times New Roman" pitchFamily="34" charset="0"/>
-                          <a:ea typeface="Times New Roman" pitchFamily="34" charset="-122"/>
-                          <a:cs typeface="Times New Roman" pitchFamily="34" charset="-120"/>
-                        </a:rPr>
-                        <a:t> overall; smaller under clouds (all‑sky +0.95 vs clear‑sky +8.9)</a:t>
-                      </a:r>
-                      <a:endParaRPr lang="en-US" sz="1400" dirty="0">
-                        <a:latin typeface="Times New Roman" charset="0"/>
-                        <a:ea typeface="Times New Roman" charset="0"/>
-                        <a:cs typeface="Times New Roman" charset="0"/>
-                      </a:endParaRPr>
-                    </a:p>
-                  </a:txBody>
-                  <a:tcPr marL="64008" marR="64008" marT="9144" marB="9144" anchor="ctr">
-                    <a:lnL w="6350" cap="flat" cmpd="sng" algn="ctr">
-                      <a:solidFill>
-                        <a:srgbClr val="D3DCE2"/>
-                      </a:solidFill>
-                      <a:prstDash val="solid"/>
-                      <a:round/>
-                      <a:headEnd type="none" w="med" len="med"/>
-                      <a:tailEnd type="none" w="med" len="med"/>
-                    </a:lnL>
-                    <a:lnR w="6350" cap="flat" cmpd="sng" algn="ctr">
-                      <a:solidFill>
-                        <a:srgbClr val="D3DCE2"/>
-                      </a:solidFill>
-                      <a:prstDash val="solid"/>
-                      <a:round/>
-                      <a:headEnd type="none" w="med" len="med"/>
-                      <a:tailEnd type="none" w="med" len="med"/>
-                    </a:lnR>
-                    <a:lnT w="6350" cap="flat" cmpd="sng" algn="ctr">
-                      <a:solidFill>
-                        <a:srgbClr val="D3DCE2"/>
-                      </a:solidFill>
-                      <a:prstDash val="solid"/>
-                      <a:round/>
-                      <a:headEnd type="none" w="med" len="med"/>
-                      <a:tailEnd type="none" w="med" len="med"/>
-                    </a:lnT>
-                    <a:lnB w="6350" cap="flat" cmpd="sng" algn="ctr">
-                      <a:solidFill>
-                        <a:srgbClr val="D3DCE2"/>
-                      </a:solidFill>
-                      <a:prstDash val="solid"/>
-                      <a:round/>
-                      <a:headEnd type="none" w="med" len="med"/>
-                      <a:tailEnd type="none" w="med" len="med"/>
-                    </a:lnB>
-                    <a:solidFill>
-                      <a:srgbClr val="EDF2F5"/>
-                    </a:solidFill>
-                  </a:tcPr>
-                </a:tc>
-                <a:tc>
-                  <a:txBody>
-                    <a:bodyPr/>
-                    <a:lstStyle/>
-                    <a:p>
-                      <a:pPr indent="0" marL="0">
-                        <a:buNone/>
-                      </a:pPr>
-                      <a:r>
-                        <a:rPr lang="en-US" sz="1400" i="1" dirty="0">
-                          <a:solidFill>
-                            <a:schemeClr val="accent1"/>
-                          </a:solidFill>
-                          <a:latin typeface="Times New Roman" pitchFamily="34" charset="0"/>
-                          <a:ea typeface="Times New Roman" pitchFamily="34" charset="-122"/>
-                          <a:cs typeface="Times New Roman" pitchFamily="34" charset="-120"/>
-                        </a:rPr>
-                        <a:t>Rap et al., 2018</a:t>
-                      </a:r>
-                      <a:endParaRPr lang="en-US" sz="1400" dirty="0">
-                        <a:latin typeface="Times New Roman" charset="0"/>
-                        <a:ea typeface="Times New Roman" charset="0"/>
-                        <a:cs typeface="Times New Roman" charset="0"/>
-                      </a:endParaRPr>
-                    </a:p>
-                    <a:p>
-                      <a:pPr indent="0" marL="0">
-                        <a:buNone/>
-                      </a:pPr>
-                      <a:r>
-                        <a:rPr lang="en-US" sz="1400" i="1" dirty="0">
-                          <a:solidFill>
-                            <a:schemeClr val="accent1"/>
-                          </a:solidFill>
-                          <a:latin typeface="Times New Roman" pitchFamily="34" charset="0"/>
-                          <a:ea typeface="Times New Roman" pitchFamily="34" charset="-122"/>
-                          <a:cs typeface="Times New Roman" pitchFamily="34" charset="-120"/>
-                        </a:rPr>
-                        <a:t>Zhou et al., 2022</a:t>
-                      </a:r>
-                      <a:endParaRPr lang="en-US" sz="1400" dirty="0">
-                        <a:latin typeface="Times New Roman" charset="0"/>
-                        <a:ea typeface="Times New Roman" charset="0"/>
-                        <a:cs typeface="Times New Roman" charset="0"/>
-                      </a:endParaRPr>
-                    </a:p>
-                    <a:p>
-                      <a:pPr indent="0" marL="0">
-                        <a:buNone/>
-                      </a:pPr>
-                      <a:r>
-                        <a:rPr lang="en-US" sz="1400" i="1" dirty="0">
-                          <a:solidFill>
-                            <a:schemeClr val="accent1"/>
-                          </a:solidFill>
-                          <a:latin typeface="Times New Roman" pitchFamily="34" charset="0"/>
-                          <a:ea typeface="Times New Roman" pitchFamily="34" charset="-122"/>
-                          <a:cs typeface="Times New Roman" pitchFamily="34" charset="-120"/>
-                        </a:rPr>
-                        <a:t>Mercado et al., 2009</a:t>
-                      </a:r>
-                      <a:endParaRPr lang="en-US" sz="1400" dirty="0">
-                        <a:latin typeface="Times New Roman" charset="0"/>
-                        <a:ea typeface="Times New Roman" charset="0"/>
-                        <a:cs typeface="Times New Roman" charset="0"/>
-                      </a:endParaRPr>
-                    </a:p>
-                  </a:txBody>
-                  <a:tcPr marL="64008" marR="64008" marT="9144" marB="9144" anchor="ctr">
-                    <a:lnL w="6350" cap="flat" cmpd="sng" algn="ctr">
-                      <a:solidFill>
-                        <a:srgbClr val="D3DCE2"/>
-                      </a:solidFill>
-                      <a:prstDash val="solid"/>
-                      <a:round/>
-                      <a:headEnd type="none" w="med" len="med"/>
-                      <a:tailEnd type="none" w="med" len="med"/>
-                    </a:lnL>
-                    <a:lnR w="6350" cap="flat" cmpd="sng" algn="ctr">
-                      <a:solidFill>
-                        <a:srgbClr val="D3DCE2"/>
-                      </a:solidFill>
-                      <a:prstDash val="solid"/>
-                      <a:round/>
-                      <a:headEnd type="none" w="med" len="med"/>
-                      <a:tailEnd type="none" w="med" len="med"/>
-                    </a:lnR>
-                    <a:lnT w="6350" cap="flat" cmpd="sng" algn="ctr">
-                      <a:solidFill>
-                        <a:srgbClr val="D3DCE2"/>
-                      </a:solidFill>
-                      <a:prstDash val="solid"/>
-                      <a:round/>
-                      <a:headEnd type="none" w="med" len="med"/>
-                      <a:tailEnd type="none" w="med" len="med"/>
-                    </a:lnT>
-                    <a:lnB w="6350" cap="flat" cmpd="sng" algn="ctr">
-                      <a:solidFill>
-                        <a:srgbClr val="D3DCE2"/>
-                      </a:solidFill>
-                      <a:prstDash val="solid"/>
-                      <a:round/>
-                      <a:headEnd type="none" w="med" len="med"/>
-                      <a:tailEnd type="none" w="med" len="med"/>
-                    </a:lnB>
-                    <a:solidFill>
-                      <a:srgbClr val="EDF2F5"/>
-                    </a:solidFill>
                   </a:tcPr>
                 </a:tc>
               </a:tr>
@@ -3220,12 +2723,12 @@
         </p:nvSpPr>
         <p:spPr>
           <a:xfrm>
-            <a:off x="9326880" y="1188720"/>
-            <a:ext cx="2404872" cy="3429000"/>
+            <a:off x="9372600" y="1325880"/>
+            <a:ext cx="2359152" cy="3252884"/>
           </a:xfrm>
           <a:prstGeom prst="roundRect">
             <a:avLst>
-              <a:gd name="adj" fmla="val 2662"/>
+              <a:gd name="adj" fmla="val 2713"/>
             </a:avLst>
           </a:prstGeom>
           <a:solidFill>
@@ -3256,8 +2759,8 @@
         </p:nvSpPr>
         <p:spPr>
           <a:xfrm>
-            <a:off x="9464040" y="1280160"/>
-            <a:ext cx="2130552" cy="758952"/>
+            <a:off x="9509760" y="1417320"/>
+            <a:ext cx="2084832" cy="530352"/>
           </a:xfrm>
           <a:prstGeom prst="rect">
             <a:avLst/>
@@ -3278,7 +2781,7 @@
                   <a:schemeClr val="tx2"/>
                 </a:solidFill>
               </a:rPr>
-              <a:t>GPP vs diffuse fraction, five boreal forest sites (Fig. 8)</a:t>
+              <a:t>GPP vs diffuse fraction, five boreal sites</a:t>
             </a:r>
             <a:endParaRPr lang="en-US" sz="1400" dirty="0"/>
           </a:p>
@@ -3300,8 +2803,8 @@
         </p:blipFill>
         <p:spPr>
           <a:xfrm>
-            <a:off x="9509399" y="2039112"/>
-            <a:ext cx="2039833" cy="1691640"/>
+            <a:off x="9500616" y="1947672"/>
+            <a:ext cx="2103120" cy="1744124"/>
           </a:xfrm>
           <a:prstGeom prst="rect">
             <a:avLst/>
@@ -3316,8 +2819,8 @@
         </p:nvSpPr>
         <p:spPr>
           <a:xfrm>
-            <a:off x="9464040" y="3803904"/>
-            <a:ext cx="2130552" cy="457200"/>
+            <a:off x="9509760" y="3764948"/>
+            <a:ext cx="2084832" cy="457200"/>
           </a:xfrm>
           <a:prstGeom prst="rect">
             <a:avLst/>
@@ -3338,7 +2841,7 @@
                   <a:schemeClr val="tx1"/>
                 </a:solidFill>
               </a:rPr>
-              <a:t>GPP peaks at intermediate diffuse fraction</a:t>
+              <a:t>GPP peaks at an intermediate diffuse fraction</a:t>
             </a:r>
             <a:endParaRPr lang="en-US" sz="1400" dirty="0"/>
           </a:p>
@@ -3352,8 +2855,8 @@
         </p:nvSpPr>
         <p:spPr>
           <a:xfrm>
-            <a:off x="9464040" y="4261104"/>
-            <a:ext cx="2130552" cy="246888"/>
+            <a:off x="9509760" y="4222148"/>
+            <a:ext cx="2084832" cy="246888"/>
           </a:xfrm>
           <a:prstGeom prst="rect">
             <a:avLst/>
@@ -3374,7 +2877,7 @@
                   <a:schemeClr val="accent1"/>
                 </a:solidFill>
               </a:rPr>
-              <a:t>Source: Ezhova et al., 2018</a:t>
+              <a:t>Ezhova et al., 2018</a:t>
             </a:r>
             <a:endParaRPr lang="en-US" sz="1400" dirty="0"/>
           </a:p>
@@ -3382,54 +2885,18 @@
       </p:sp>
       <p:sp>
         <p:nvSpPr>
-          <p:cNvPr id="10" name="Crop note"/>
-          <p:cNvSpPr txBox="1"/>
-          <p:nvPr/>
-        </p:nvSpPr>
-        <p:spPr>
-          <a:xfrm>
-            <a:off x="9326880" y="4846320"/>
-            <a:ext cx="2404872" cy="274320"/>
-          </a:xfrm>
-          <a:prstGeom prst="rect">
-            <a:avLst/>
-          </a:prstGeom>
-          <a:noFill/>
-          <a:ln/>
-        </p:spPr>
-        <p:txBody>
-          <a:bodyPr wrap="square" lIns="0" tIns="0" rIns="0" bIns="0" rtlCol="0" anchor="t"/>
-          <a:lstStyle/>
-          <a:p>
-            <a:pPr indent="0" marL="0">
-              <a:buNone/>
-            </a:pPr>
-            <a:r>
-              <a:rPr lang="en-US" sz="1400" i="1" dirty="0">
-                <a:solidFill>
-                  <a:srgbClr val="5A6B78"/>
-                </a:solidFill>
-              </a:rPr>
-              <a:t>Crop ecosystems excluded</a:t>
-            </a:r>
-            <a:endParaRPr lang="en-US" sz="1400" dirty="0"/>
-          </a:p>
-        </p:txBody>
-      </p:sp>
-      <p:sp>
-        <p:nvSpPr>
-          <p:cNvPr id="11" name="Condition strip"/>
+          <p:cNvPr id="10" name="Condition strip"/>
           <p:cNvSpPr/>
           <p:nvPr/>
         </p:nvSpPr>
         <p:spPr>
           <a:xfrm>
-            <a:off x="457200" y="5687568"/>
-            <a:ext cx="11274552" cy="658368"/>
+            <a:off x="457200" y="5852160"/>
+            <a:ext cx="11274552" cy="457200"/>
           </a:xfrm>
           <a:prstGeom prst="roundRect">
             <a:avLst>
-              <a:gd name="adj" fmla="val 8333"/>
+              <a:gd name="adj" fmla="val 12000"/>
             </a:avLst>
           </a:prstGeom>
           <a:solidFill>
@@ -3445,14 +2912,14 @@
       </p:sp>
       <p:sp>
         <p:nvSpPr>
-          <p:cNvPr id="12" name="Condition strip text"/>
+          <p:cNvPr id="11" name="Condition strip text"/>
           <p:cNvSpPr txBox="1"/>
           <p:nvPr/>
         </p:nvSpPr>
         <p:spPr>
           <a:xfrm>
-            <a:off x="594360" y="5687568"/>
-            <a:ext cx="11000232" cy="658368"/>
+            <a:off x="594360" y="5852160"/>
+            <a:ext cx="11000232" cy="457200"/>
           </a:xfrm>
           <a:prstGeom prst="rect">
             <a:avLst/>
@@ -3473,7 +2940,7 @@
                   <a:schemeClr val="tx1"/>
                 </a:solidFill>
               </a:rPr>
-              <a:t>Positive when:</a:t>
+              <a:t>Positive:</a:t>
             </a:r>
             <a:r>
               <a:rPr lang="en-US" sz="1400" dirty="0">
@@ -3481,7 +2948,7 @@
                   <a:schemeClr val="tx1"/>
                 </a:solidFill>
               </a:rPr>
-              <a:t> scattering aerosol, moderate AOD, deep multilayer canopy, clear skies.   </a:t>
+              <a:t> scattering aerosol, moderate load, deep canopy, clear sky      </a:t>
             </a:r>
             <a:r>
               <a:rPr lang="en-US" sz="1400" b="1" dirty="0">
@@ -3489,7 +2956,7 @@
                   <a:schemeClr val="tx1"/>
                 </a:solidFill>
               </a:rPr>
-              <a:t>Negative when:</a:t>
+              <a:t>Negative:</a:t>
             </a:r>
             <a:r>
               <a:rPr lang="en-US" sz="1400" dirty="0">
@@ -3497,7 +2964,7 @@
                   <a:schemeClr val="tx1"/>
                 </a:solidFill>
               </a:rPr>
-              <a:t> very high AOD (&gt; 0.6 grassland, &gt; 1.7 tropical forest), absorbing black carbon, short open canopy.</a:t>
+              <a:t> very heavy load, black carbon, short open canopy</a:t>
             </a:r>
             <a:endParaRPr lang="en-US" sz="1400" dirty="0"/>
           </a:p>

</xml_diff>